<commit_message>
docs(defesa): o slide da demo ao vivo — o Muro em U no painel
Entra antes do «Obrigado»: a captura da Apresentacao no Muro em U (quatro
colunas, o adaptativo em destaque), o que mostrar por ordem, os dois
enderecos do painel e o plano B (o GIF do slide 9) se a rede ou o portatil
falharem. As notas de orador tem o minuto falado.

Claude-Session: https://claude.ai/code/session_01As6PprrxSvVLUbmc7VAyZV
</commit_message>
<xml_diff>
--- a/Defesa/slides_defesa.pptx
+++ b/Defesa/slides_defesa.pptx
@@ -23,6 +23,7 @@
     <p:sldId id="271" r:id="rId23"/>
     <p:sldId id="272" r:id="rId24"/>
     <p:sldId id="273" r:id="rId25"/>
+    <p:sldId id="274" r:id="rId26"/>
   </p:sldIdLst>
   <p:sldSz cx="12191695" cy="6858000" type="screen4x3"/>
   <p:notesSz cx="6858000" cy="9144000"/>
@@ -1360,6 +1361,111 @@
 </file>
 
 <file path=ppt/notesSlides/notesSlide18.xml><?xml version="1.0" encoding="utf-8"?>
+<p:notes xmlns:a="http://schemas.openxmlformats.org/drawingml/2006/main" xmlns:p="http://schemas.openxmlformats.org/presentationml/2006/main" xmlns:r="http://schemas.openxmlformats.org/officeDocument/2006/relationships">
+  <p:cSld>
+    <p:spTree>
+      <p:nvGrpSpPr>
+        <p:cNvPr id="1" name=""/>
+        <p:cNvGrpSpPr/>
+        <p:nvPr/>
+      </p:nvGrpSpPr>
+      <p:grpSpPr>
+        <a:xfrm>
+          <a:off x="0" y="0"/>
+          <a:ext cx="0" cy="0"/>
+          <a:chOff x="0" y="0"/>
+          <a:chExt cx="0" cy="0"/>
+        </a:xfrm>
+      </p:grpSpPr>
+      <p:sp>
+        <p:nvSpPr>
+          <p:cNvPr id="2" name="Slide Image Placeholder 1"/>
+          <p:cNvSpPr>
+            <a:spLocks noGrp="1"/>
+          </p:cNvSpPr>
+          <p:nvPr>
+            <p:ph type="sldImg" idx="2"/>
+          </p:nvPr>
+        </p:nvSpPr>
+        <p:spPr/>
+      </p:sp>
+      <p:sp>
+        <p:nvSpPr>
+          <p:cNvPr id="3" name="Notes Placeholder 2"/>
+          <p:cNvSpPr>
+            <a:spLocks noGrp="1"/>
+          </p:cNvSpPr>
+          <p:nvPr>
+            <p:ph type="body" idx="3" sz="quarter"/>
+          </p:nvPr>
+        </p:nvSpPr>
+        <p:spPr/>
+        <p:txBody>
+          <a:bodyPr/>
+          <a:lstStyle/>
+          <a:p>
+            <a:r>
+              <a:t>Antes das perguntas, um minuto ao vivo. Abro o painel na Apresentação, mapa dois:</a:t>
+            </a:r>
+          </a:p>
+          <a:p>
+            <a:r>
+              <a:t>o Muro em U. Três colunas com os modelos da campanha final — repare-se que cada</a:t>
+            </a:r>
+          </a:p>
+          <a:p>
+            <a:r>
+              <a:t>execução ou aprende o desvio ou fica a zero: três em sete, quatro em sete, duas</a:t>
+            </a:r>
+          </a:p>
+          <a:p>
+            <a:r>
+              <a:t>em sete. A quarta coluna é o GNN com novidade doseada adaptativamente: sete em</a:t>
+            </a:r>
+          </a:p>
+          <a:p>
+            <a:r>
+              <a:t>sete, setenta e oito recolhas. Carrego em Episódio 3D e os quatro enxames</a:t>
+            </a:r>
+          </a:p>
+          <a:p>
+            <a:r>
+              <a:t>correm ao mesmo tempo. Em baixo, o dot plot com a linha do adaptativo e as</a:t>
+            </a:r>
+          </a:p>
+          <a:p>
+            <a:r>
+              <a:t>curvas de treino. Qualquer número do painel tem proveniência: dois cliques até</a:t>
+            </a:r>
+          </a:p>
+          <a:p>
+            <a:r>
+              <a:t>ao CSV. Plano B se a rede ou o portátil falharem: o GIF do slide nove.</a:t>
+            </a:r>
+          </a:p>
+        </p:txBody>
+      </p:sp>
+      <p:sp>
+        <p:nvSpPr>
+          <p:cNvPr id="4" name="Slide Number Placeholder 3"/>
+          <p:cNvSpPr>
+            <a:spLocks noGrp="1"/>
+          </p:cNvSpPr>
+          <p:nvPr>
+            <p:ph type="sldNum" idx="5" sz="quarter"/>
+          </p:nvPr>
+        </p:nvSpPr>
+        <p:spPr/>
+      </p:sp>
+    </p:spTree>
+  </p:cSld>
+  <p:clrMapOvr>
+    <a:masterClrMapping/>
+  </p:clrMapOvr>
+</p:notes>
+</file>
+
+<file path=ppt/notesSlides/notesSlide19.xml><?xml version="1.0" encoding="utf-8"?>
 <p:notes xmlns:a="http://schemas.openxmlformats.org/drawingml/2006/main" xmlns:p="http://schemas.openxmlformats.org/presentationml/2006/main" xmlns:r="http://schemas.openxmlformats.org/officeDocument/2006/relationships">
   <p:cSld>
     <p:spTree>
@@ -9785,6 +9891,441 @@
         </p:nvSpPr>
         <p:spPr>
           <a:xfrm>
+            <a:off x="548640" y="320040"/>
+            <a:ext cx="11094415" cy="731520"/>
+          </a:xfrm>
+          <a:prstGeom prst="rect">
+            <a:avLst/>
+          </a:prstGeom>
+          <a:noFill/>
+        </p:spPr>
+        <p:txBody>
+          <a:bodyPr wrap="square" anchor="t">
+            <a:spAutoFit/>
+          </a:bodyPr>
+          <a:lstStyle/>
+          <a:p>
+            <a:pPr algn="l">
+              <a:spcAft>
+                <a:spcPts val="600"/>
+              </a:spcAft>
+            </a:pPr>
+            <a:r>
+              <a:rPr sz="3000" b="1">
+                <a:solidFill>
+                  <a:srgbClr val="1A1A1A"/>
+                </a:solidFill>
+                <a:latin typeface="Calibri"/>
+              </a:rPr>
+              <a:t>Demo ao vivo — o Muro em U no painel</a:t>
+            </a:r>
+          </a:p>
+        </p:txBody>
+      </p:sp>
+      <p:sp>
+        <p:nvSpPr>
+          <p:cNvPr id="3" name="TextBox 2"/>
+          <p:cNvSpPr txBox="1"/>
+          <p:nvPr/>
+        </p:nvSpPr>
+        <p:spPr>
+          <a:xfrm>
+            <a:off x="548640" y="960120"/>
+            <a:ext cx="11094415" cy="457200"/>
+          </a:xfrm>
+          <a:prstGeom prst="rect">
+            <a:avLst/>
+          </a:prstGeom>
+          <a:noFill/>
+        </p:spPr>
+        <p:txBody>
+          <a:bodyPr wrap="square" anchor="t">
+            <a:spAutoFit/>
+          </a:bodyPr>
+          <a:lstStyle/>
+          <a:p>
+            <a:pPr algn="l">
+              <a:spcAft>
+                <a:spcPts val="600"/>
+              </a:spcAft>
+            </a:pPr>
+            <a:r>
+              <a:rPr sz="1500" b="0">
+                <a:solidFill>
+                  <a:srgbClr val="6B6B6B"/>
+                </a:solidFill>
+                <a:latin typeface="Calibri"/>
+              </a:rPr>
+              <a:t>os três modelos a correr lado a lado, o vencedor em destaque, e a proveniência de cada número</a:t>
+            </a:r>
+          </a:p>
+        </p:txBody>
+      </p:sp>
+      <p:cxnSp>
+        <p:nvCxnSpPr>
+          <p:cNvPr id="4" name="Connector 3"/>
+          <p:cNvCxnSpPr/>
+          <p:nvPr/>
+        </p:nvCxnSpPr>
+        <p:spPr>
+          <a:xfrm>
+            <a:off x="548640" y="1371600"/>
+            <a:ext cx="1097280" cy="0"/>
+          </a:xfrm>
+          <a:prstGeom prst="line">
+            <a:avLst/>
+          </a:prstGeom>
+          <a:ln w="38100">
+            <a:solidFill>
+              <a:srgbClr val="0B3D91"/>
+            </a:solidFill>
+          </a:ln>
+        </p:spPr>
+        <p:style>
+          <a:lnRef idx="2">
+            <a:schemeClr val="accent1"/>
+          </a:lnRef>
+          <a:fillRef idx="0">
+            <a:schemeClr val="accent1"/>
+          </a:fillRef>
+          <a:effectRef idx="1">
+            <a:schemeClr val="accent1"/>
+          </a:effectRef>
+          <a:fontRef idx="minor">
+            <a:schemeClr val="tx1"/>
+          </a:fontRef>
+        </p:style>
+      </p:cxnSp>
+      <p:pic>
+        <p:nvPicPr>
+          <p:cNvPr id="5" name="Picture 4" descr="demo_muro_em_u.jpg"/>
+          <p:cNvPicPr>
+            <a:picLocks noChangeAspect="1"/>
+          </p:cNvPicPr>
+          <p:nvPr/>
+        </p:nvPicPr>
+        <p:blipFill>
+          <a:blip r:embed="rId2"/>
+          <a:stretch>
+            <a:fillRect/>
+          </a:stretch>
+        </p:blipFill>
+        <p:spPr>
+          <a:xfrm>
+            <a:off x="548640" y="1554480"/>
+            <a:ext cx="7589520" cy="3702795"/>
+          </a:xfrm>
+          <a:prstGeom prst="rect">
+            <a:avLst/>
+          </a:prstGeom>
+        </p:spPr>
+      </p:pic>
+      <p:sp>
+        <p:nvSpPr>
+          <p:cNvPr id="6" name="TextBox 5"/>
+          <p:cNvSpPr txBox="1"/>
+          <p:nvPr/>
+        </p:nvSpPr>
+        <p:spPr>
+          <a:xfrm>
+            <a:off x="8412480" y="1554480"/>
+            <a:ext cx="3230575" cy="4480560"/>
+          </a:xfrm>
+          <a:prstGeom prst="rect">
+            <a:avLst/>
+          </a:prstGeom>
+          <a:noFill/>
+        </p:spPr>
+        <p:txBody>
+          <a:bodyPr wrap="square" anchor="t">
+            <a:spAutoFit/>
+          </a:bodyPr>
+          <a:lstStyle/>
+          <a:p>
+            <a:pPr algn="l">
+              <a:spcAft>
+                <a:spcPts val="600"/>
+              </a:spcAft>
+            </a:pPr>
+            <a:r>
+              <a:rPr sz="1500" b="1">
+                <a:solidFill>
+                  <a:srgbClr val="0B3D91"/>
+                </a:solidFill>
+                <a:latin typeface="Calibri"/>
+              </a:rPr>
+              <a:t>O que mostrar, por esta ordem</a:t>
+            </a:r>
+          </a:p>
+          <a:p>
+            <a:pPr algn="l">
+              <a:spcAft>
+                <a:spcPts val="600"/>
+              </a:spcAft>
+            </a:pPr>
+            <a:r>
+              <a:rPr sz="1300" b="0">
+                <a:solidFill>
+                  <a:srgbClr val="1A1A1A"/>
+                </a:solidFill>
+                <a:latin typeface="Calibri"/>
+              </a:rPr>
+              <a:t>1. Os três da campanha final: 3/7, 4/7 e 2/7 — cada execução ou aprende o desvio ou fica a zero</a:t>
+            </a:r>
+          </a:p>
+          <a:p>
+            <a:pPr algn="l">
+              <a:spcAft>
+                <a:spcPts val="600"/>
+              </a:spcAft>
+            </a:pPr>
+            <a:r>
+              <a:rPr sz="1300" b="0">
+                <a:solidFill>
+                  <a:srgbClr val="1A1A1A"/>
+                </a:solidFill>
+                <a:latin typeface="Calibri"/>
+              </a:rPr>
+              <a:t>2. A 4.ª coluna: o GNN com novidade adaptativa — 7/7, 77,8 rec/ep (o «melhor»)</a:t>
+            </a:r>
+          </a:p>
+          <a:p>
+            <a:pPr algn="l">
+              <a:spcAft>
+                <a:spcPts val="600"/>
+              </a:spcAft>
+            </a:pPr>
+            <a:r>
+              <a:rPr sz="1300" b="0">
+                <a:solidFill>
+                  <a:srgbClr val="1A1A1A"/>
+                </a:solidFill>
+                <a:latin typeface="Calibri"/>
+              </a:rPr>
+              <a:t>3. Toggle «Episódio 3D»: os quatro enxames em 3D ao mesmo tempo; arrastar para rodar</a:t>
+            </a:r>
+          </a:p>
+          <a:p>
+            <a:pPr algn="l">
+              <a:spcAft>
+                <a:spcPts val="600"/>
+              </a:spcAft>
+            </a:pPr>
+            <a:r>
+              <a:rPr sz="1300" b="0">
+                <a:solidFill>
+                  <a:srgbClr val="1A1A1A"/>
+                </a:solidFill>
+                <a:latin typeface="Calibri"/>
+              </a:rPr>
+              <a:t>4. Em baixo: o dot plot com a linha do adaptativo, e as curvas de treino</a:t>
+            </a:r>
+          </a:p>
+          <a:p>
+            <a:pPr algn="l">
+              <a:spcAft>
+                <a:spcPts val="600"/>
+              </a:spcAft>
+            </a:pPr>
+            <a:r>
+              <a:rPr sz="1300" b="0">
+                <a:solidFill>
+                  <a:srgbClr val="1A1A1A"/>
+                </a:solidFill>
+                <a:latin typeface="Calibri"/>
+              </a:rPr>
+              <a:t>5. Se perguntarem «de onde vem este número?»: Proveniência — dois cliques até ao CSV</a:t>
+            </a:r>
+          </a:p>
+          <a:p>
+            <a:pPr algn="l">
+              <a:spcAft>
+                <a:spcPts val="600"/>
+              </a:spcAft>
+            </a:pPr>
+            <a:r>
+              <a:rPr sz="800" b="0">
+                <a:solidFill>
+                  <a:srgbClr val="1A1A1A"/>
+                </a:solidFill>
+                <a:latin typeface="Calibri"/>
+              </a:rPr>
+              <a:t/>
+            </a:r>
+          </a:p>
+          <a:p>
+            <a:pPr algn="l">
+              <a:spcAft>
+                <a:spcPts val="600"/>
+              </a:spcAft>
+            </a:pPr>
+            <a:r>
+              <a:rPr sz="1200" b="0">
+                <a:solidFill>
+                  <a:srgbClr val="6B6B6B"/>
+                </a:solidFill>
+                <a:latin typeface="Calibri"/>
+              </a:rPr>
+              <a:t>Painel: localhost:8080 (portátil) · swarmroboticsgs.duckdns.org (Pi)</a:t>
+            </a:r>
+          </a:p>
+          <a:p>
+            <a:pPr algn="l">
+              <a:spcAft>
+                <a:spcPts val="600"/>
+              </a:spcAft>
+            </a:pPr>
+            <a:r>
+              <a:rPr sz="1200" b="0">
+                <a:solidFill>
+                  <a:srgbClr val="6B6B6B"/>
+                </a:solidFill>
+                <a:latin typeface="Calibri"/>
+              </a:rPr>
+              <a:t>Setas do teclado mudam de mapa · plano B: o GIF do Muro em U no slide 9</a:t>
+            </a:r>
+          </a:p>
+        </p:txBody>
+      </p:sp>
+      <p:cxnSp>
+        <p:nvCxnSpPr>
+          <p:cNvPr id="7" name="Connector 6"/>
+          <p:cNvCxnSpPr/>
+          <p:nvPr/>
+        </p:nvCxnSpPr>
+        <p:spPr>
+          <a:xfrm>
+            <a:off x="548640" y="6355080"/>
+            <a:ext cx="11094415" cy="0"/>
+          </a:xfrm>
+          <a:prstGeom prst="line">
+            <a:avLst/>
+          </a:prstGeom>
+          <a:ln w="9525">
+            <a:solidFill>
+              <a:srgbClr val="D0D0D0"/>
+            </a:solidFill>
+          </a:ln>
+        </p:spPr>
+        <p:style>
+          <a:lnRef idx="2">
+            <a:schemeClr val="accent1"/>
+          </a:lnRef>
+          <a:fillRef idx="0">
+            <a:schemeClr val="accent1"/>
+          </a:fillRef>
+          <a:effectRef idx="1">
+            <a:schemeClr val="accent1"/>
+          </a:effectRef>
+          <a:fontRef idx="minor">
+            <a:schemeClr val="tx1"/>
+          </a:fontRef>
+        </p:style>
+      </p:cxnSp>
+      <p:sp>
+        <p:nvSpPr>
+          <p:cNvPr id="8" name="TextBox 7"/>
+          <p:cNvSpPr txBox="1"/>
+          <p:nvPr/>
+        </p:nvSpPr>
+        <p:spPr>
+          <a:xfrm>
+            <a:off x="548640" y="6400800"/>
+            <a:ext cx="8229600" cy="365760"/>
+          </a:xfrm>
+          <a:prstGeom prst="rect">
+            <a:avLst/>
+          </a:prstGeom>
+          <a:noFill/>
+        </p:spPr>
+        <p:txBody>
+          <a:bodyPr wrap="square" anchor="t">
+            <a:spAutoFit/>
+          </a:bodyPr>
+          <a:lstStyle/>
+          <a:p>
+            <a:pPr algn="l">
+              <a:spcAft>
+                <a:spcPts val="600"/>
+              </a:spcAft>
+            </a:pPr>
+            <a:r>
+              <a:rPr sz="1000" b="0">
+                <a:solidFill>
+                  <a:srgbClr val="6B6B6B"/>
+                </a:solidFill>
+                <a:latin typeface="Calibri"/>
+              </a:rPr>
+              <a:t>Aprendizagem por Reforço para Controlo de Enxames · ISCTE-IUL 2026</a:t>
+            </a:r>
+          </a:p>
+        </p:txBody>
+      </p:sp>
+      <p:sp>
+        <p:nvSpPr>
+          <p:cNvPr id="9" name="TextBox 8"/>
+          <p:cNvSpPr txBox="1"/>
+          <p:nvPr/>
+        </p:nvSpPr>
+        <p:spPr>
+          <a:xfrm>
+            <a:off x="10728655" y="6400800"/>
+            <a:ext cx="914400" cy="365760"/>
+          </a:xfrm>
+          <a:prstGeom prst="rect">
+            <a:avLst/>
+          </a:prstGeom>
+          <a:noFill/>
+        </p:spPr>
+        <p:txBody>
+          <a:bodyPr wrap="square" anchor="t">
+            <a:spAutoFit/>
+          </a:bodyPr>
+          <a:lstStyle/>
+          <a:p>
+            <a:pPr algn="r">
+              <a:spcAft>
+                <a:spcPts val="600"/>
+              </a:spcAft>
+            </a:pPr>
+            <a:r>
+              <a:rPr sz="1000" b="0">
+                <a:solidFill>
+                  <a:srgbClr val="6B6B6B"/>
+                </a:solidFill>
+                <a:latin typeface="Calibri"/>
+              </a:rPr>
+              <a:t>17</a:t>
+            </a:r>
+          </a:p>
+        </p:txBody>
+      </p:sp>
+    </p:spTree>
+  </p:cSld>
+  <p:clrMapOvr>
+    <a:masterClrMapping/>
+  </p:clrMapOvr>
+</p:sld>
+</file>
+
+<file path=ppt/slides/slide19.xml><?xml version="1.0" encoding="utf-8"?>
+<p:sld xmlns:a="http://schemas.openxmlformats.org/drawingml/2006/main" xmlns:p="http://schemas.openxmlformats.org/presentationml/2006/main" xmlns:r="http://schemas.openxmlformats.org/officeDocument/2006/relationships">
+  <p:cSld>
+    <p:spTree>
+      <p:nvGrpSpPr>
+        <p:cNvPr id="1" name=""/>
+        <p:cNvGrpSpPr/>
+        <p:nvPr/>
+      </p:nvGrpSpPr>
+      <p:grpSpPr/>
+      <p:sp>
+        <p:nvSpPr>
+          <p:cNvPr id="2" name="TextBox 1"/>
+          <p:cNvSpPr txBox="1"/>
+          <p:nvPr/>
+        </p:nvSpPr>
+        <p:spPr>
+          <a:xfrm>
             <a:off x="548640" y="2194560"/>
             <a:ext cx="11094415" cy="1097280"/>
           </a:xfrm>

</xml_diff>

<commit_message>
fix(defesa): os slides acompanham o título novo e perdem as «recolhas»
- Capa: o título completo, com «Desempenho, Escalabilidade e Robustez»
  no lugar do subtítulo descritivo.
- Notas do orador do slide 1: diziam ainda o título antigo.
- Slide «O protocolo»: o gráfico de barras era a cópia de 7 set, com
  «Recolhas» no título e no eixo; passa a ser a de final_7d (14 set),
  gerada pelo mesmo script com «Chegadas».
- Números com milhares («2 940», «1 680», ...) com espaço inquebrável,
  para não partirem na mudança de linha; «o fitness» → «a fitness»,
  como na tese.
</commit_message>
<xml_diff>
--- a/Defesa/slides_defesa.pptx
+++ b/Defesa/slides_defesa.pptx
@@ -533,12 +533,12 @@
           <a:p/>
           <a:p>
             <a:r>
-              <a:t>Bom dia. Vou apresentar a dissertação «Aprendizagem por Reforço para Controlo de</a:t>
-            </a:r>
-          </a:p>
-          <a:p>
-            <a:r>
-              <a:t>Enxames»: uma comparação, no mesmo simulador e com o mesmo protocolo, entre dois</a:t>
+              <a:t>Bom dia. Vou apresentar a dissertação «Aprendizagem por Reforço Multiagente e Neuroevolução no Controlo de Enxames de Robôs: Desempenho,</a:t>
+            </a:r>
+          </a:p>
+          <a:p>
+            <a:r>
+              <a:t>Escalabilidade e Robustez»: uma comparação, no mesmo simulador e com o mesmo protocolo, entre dois</a:t>
             </a:r>
           </a:p>
           <a:p>
@@ -6992,13 +6992,13 @@
               </a:spcAft>
             </a:pPr>
             <a:r>
-              <a:rPr sz="4000" b="1">
+              <a:rPr sz="2800" b="1">
                 <a:solidFill>
                   <a:srgbClr val="F5F5F5"/>
                 </a:solidFill>
                 <a:latin typeface="Segoe UI Semibold"/>
               </a:rPr>
-              <a:t>Aprendizagem por Reforço para Controlo de Enxames</a:t>
+              <a:t>Aprendizagem por Reforço Multiagente e Neuroevolução no Controlo de Enxames de Robôs:</a:t>
             </a:r>
           </a:p>
         </p:txBody>
@@ -7031,13 +7031,13 @@
               </a:spcAft>
             </a:pPr>
             <a:r>
-              <a:rPr sz="1900" b="0">
+              <a:rPr sz="2200" b="0">
                 <a:solidFill>
                   <a:srgbClr val="9A9A9A"/>
                 </a:solidFill>
                 <a:latin typeface="Segoe UI"/>
               </a:rPr>
-              <a:t>Aprendizagem por reforço multiagente por gradiente vs. neuroevolução com atenção sobre grafo, em oito cenários de dificuldade crescente</a:t>
+              <a:t>Desempenho, Escalabilidade e Robustez</a:t>
             </a:r>
           </a:p>
         </p:txBody>
@@ -7565,7 +7565,7 @@
                 </a:solidFill>
                 <a:latin typeface="Segoe UI"/>
               </a:rPr>
-              <a:t>Aprendizagem por Reforço para Controlo de Enxames · ISCTE-IUL 2026</a:t>
+              <a:t>Aprendizagem por Reforço Multiagente e Neuroevolução · ISCTE-IUL 2026</a:t>
             </a:r>
           </a:p>
         </p:txBody>
@@ -9150,7 +9150,7 @@
                 </a:solidFill>
                 <a:latin typeface="Segoe UI"/>
               </a:rPr>
-              <a:t>Aprendizagem por Reforço para Controlo de Enxames · ISCTE-IUL 2026</a:t>
+              <a:t>Aprendizagem por Reforço Multiagente e Neuroevolução · ISCTE-IUL 2026</a:t>
             </a:r>
           </a:p>
         </p:txBody>
@@ -11921,7 +11921,7 @@
                 </a:solidFill>
                 <a:latin typeface="Segoe UI"/>
               </a:rPr>
-              <a:t>Aprendizagem por Reforço para Controlo de Enxames · ISCTE-IUL 2026</a:t>
+              <a:t>Aprendizagem por Reforço Multiagente e Neuroevolução · ISCTE-IUL 2026</a:t>
             </a:r>
           </a:p>
         </p:txBody>
@@ -12439,7 +12439,7 @@
                 </a:solidFill>
                 <a:latin typeface="Segoe UI"/>
               </a:rPr>
-              <a:t>Aprendizagem por Reforço para Controlo de Enxames · ISCTE-IUL 2026</a:t>
+              <a:t>Aprendizagem por Reforço Multiagente e Neuroevolução · ISCTE-IUL 2026</a:t>
             </a:r>
           </a:p>
         </p:txBody>
@@ -13108,7 +13108,7 @@
                 </a:solidFill>
                 <a:latin typeface="Segoe UI"/>
               </a:rPr>
-              <a:t>Sem retreino: zero chegadas em 84 de 84 células (1 680 episódios) — e o mapa é resolúvel: um navegador geodésico sem aprendizagem faz 53,0 chegadas/ep</a:t>
+              <a:t>Sem retreino: zero chegadas em 84 de 84 células (1 680 episódios) — e o mapa é resolúvel: um navegador geodésico sem aprendizagem faz 53,0 chegadas/ep</a:t>
             </a:r>
           </a:p>
           <a:p>
@@ -13223,7 +13223,7 @@
                 </a:solidFill>
                 <a:latin typeface="Segoe UI"/>
               </a:rPr>
-              <a:t>Aprendizagem por Reforço para Controlo de Enxames · ISCTE-IUL 2026</a:t>
+              <a:t>Aprendizagem por Reforço Multiagente e Neuroevolução · ISCTE-IUL 2026</a:t>
             </a:r>
           </a:p>
         </p:txBody>
@@ -14449,7 +14449,7 @@
                 </a:solidFill>
                 <a:latin typeface="Segoe UI"/>
               </a:rPr>
-              <a:t>Aprendizagem por Reforço para Controlo de Enxames · ISCTE-IUL 2026</a:t>
+              <a:t>Aprendizagem por Reforço Multiagente e Neuroevolução · ISCTE-IUL 2026</a:t>
             </a:r>
           </a:p>
         </p:txBody>
@@ -15017,7 +15017,7 @@
                 </a:solidFill>
                 <a:latin typeface="Segoe UI"/>
               </a:rPr>
-              <a:t>Aprendizagem por Reforço para Controlo de Enxames · ISCTE-IUL 2026</a:t>
+              <a:t>Aprendizagem por Reforço Multiagente e Neuroevolução · ISCTE-IUL 2026</a:t>
             </a:r>
           </a:p>
         </p:txBody>
@@ -15524,7 +15524,7 @@
                 </a:solidFill>
                 <a:latin typeface="Segoe UI"/>
               </a:rPr>
-              <a:t>Aprendizagem por Reforço para Controlo de Enxames · ISCTE-IUL 2026</a:t>
+              <a:t>Aprendizagem por Reforço Multiagente e Neuroevolução · ISCTE-IUL 2026</a:t>
             </a:r>
           </a:p>
         </p:txBody>
@@ -15934,7 +15934,7 @@
                 </a:solidFill>
                 <a:latin typeface="Segoe UI"/>
               </a:rPr>
-              <a:t>Aprendizagem por Reforço para Controlo de Enxames · ISCTE-IUL 2026</a:t>
+              <a:t>Aprendizagem por Reforço Multiagente e Neuroevolução · ISCTE-IUL 2026</a:t>
             </a:r>
           </a:p>
         </p:txBody>
@@ -16496,7 +16496,7 @@
                 </a:solidFill>
                 <a:latin typeface="Segoe UI"/>
               </a:rPr>
-              <a:t>Aprendizagem por Reforço para Controlo de Enxames · ISCTE-IUL 2026</a:t>
+              <a:t>Aprendizagem por Reforço Multiagente e Neuroevolução · ISCTE-IUL 2026</a:t>
             </a:r>
           </a:p>
         </p:txBody>
@@ -17739,7 +17739,7 @@
                 </a:solidFill>
                 <a:latin typeface="Segoe UI"/>
               </a:rPr>
-              <a:t>Aprendizagem por Reforço para Controlo de Enxames · ISCTE-IUL 2026</a:t>
+              <a:t>Aprendizagem por Reforço Multiagente e Neuroevolução · ISCTE-IUL 2026</a:t>
             </a:r>
           </a:p>
         </p:txBody>
@@ -22099,7 +22099,7 @@
                         </a:defRPr>
                       </a:pPr>
                       <a:r>
-                        <a:t>zero chegadas em 84/84 células · 1 680 episódios</a:t>
+                        <a:t>zero chegadas em 84/84 células · 1 680 episódios</a:t>
                       </a:r>
                     </a:p>
                   </a:txBody>
@@ -22683,7 +22683,7 @@
                         </a:defRPr>
                       </a:pPr>
                       <a:r>
-                        <a:t>em 19 das 21 execuções o fitness ainda subia no último quinto</a:t>
+                        <a:t>em 19 das 21 execuções a fitness ainda subia no último quinto</a:t>
                       </a:r>
                     </a:p>
                   </a:txBody>
@@ -23113,7 +23113,7 @@
                 </a:solidFill>
                 <a:latin typeface="Segoe UI"/>
               </a:rPr>
-              <a:t>Campanha principal: 147 treinos e 2 940 episódios de avaliação. Projeto inteiro: 28 sessões e 2 078 h de treino, das quais 341 h do mega-treino de um mês.</a:t>
+              <a:t>Campanha principal: 147 treinos e 2 940 episódios de avaliação. Projeto inteiro: 28 sessões e 2 078 h de treino, das quais 341 h do mega-treino de um mês.</a:t>
             </a:r>
           </a:p>
           <a:p>
@@ -25033,7 +25033,7 @@
                 </a:solidFill>
                 <a:latin typeface="Segoe UI"/>
               </a:rPr>
-              <a:t>Cobertura medida, não alegada: 1 043 dos 2 286 tokens numéricos do corpo do main.tex são lidos por algum verificador (46 %), e os 193 automatizáveis que faltam estão listados, um a um, em docs/COBERTURA_VERIFICADOR.md</a:t>
+              <a:t>Cobertura medida, não alegada: 1 043 dos 2 286 tokens numéricos do corpo do main.tex são lidos por algum verificador (46 %), e os 193 automatizáveis que faltam estão listados, um a um, em docs/COBERTURA_VERIFICADOR.md</a:t>
             </a:r>
           </a:p>
           <a:p>
@@ -25723,7 +25723,7 @@
                 </a:solidFill>
                 <a:latin typeface="Segoe UI"/>
               </a:rPr>
-              <a:t>Aprendizagem por Reforço para Controlo de Enxames · ISCTE-IUL 2026</a:t>
+              <a:t>Aprendizagem por Reforço Multiagente e Neuroevolução · ISCTE-IUL 2026</a:t>
             </a:r>
           </a:p>
         </p:txBody>
@@ -26276,7 +26276,7 @@
                 </a:solidFill>
                 <a:latin typeface="Segoe UI"/>
               </a:rPr>
-              <a:t>Aprendizagem por Reforço para Controlo de Enxames · ISCTE-IUL 2026</a:t>
+              <a:t>Aprendizagem por Reforço Multiagente e Neuroevolução · ISCTE-IUL 2026</a:t>
             </a:r>
           </a:p>
         </p:txBody>
@@ -27355,7 +27355,7 @@
                 </a:solidFill>
                 <a:latin typeface="Segoe UI"/>
               </a:rPr>
-              <a:t>Aprendizagem por Reforço para Controlo de Enxames · ISCTE-IUL 2026</a:t>
+              <a:t>Aprendizagem por Reforço Multiagente e Neuroevolução · ISCTE-IUL 2026</a:t>
             </a:r>
           </a:p>
         </p:txBody>
@@ -28617,7 +28617,7 @@
                 </a:solidFill>
                 <a:latin typeface="Segoe UI"/>
               </a:rPr>
-              <a:t>Aprendizagem por Reforço para Controlo de Enxames · ISCTE-IUL 2026</a:t>
+              <a:t>Aprendizagem por Reforço Multiagente e Neuroevolução · ISCTE-IUL 2026</a:t>
             </a:r>
           </a:p>
         </p:txBody>
@@ -28939,7 +28939,7 @@
                 </a:solidFill>
                 <a:latin typeface="Segoe UI"/>
               </a:rPr>
-              <a:t>Avaliação determinística: 20 episódios emparelhados por modelo (sementes comuns) — 2 940 episódios na campanha principal</a:t>
+              <a:t>Avaliação determinística: 20 episódios emparelhados por modelo (sementes comuns) — 2 940 episódios na campanha principal</a:t>
             </a:r>
           </a:p>
           <a:p>
@@ -29185,7 +29185,7 @@
                 </a:solidFill>
                 <a:latin typeface="Segoe UI"/>
               </a:rPr>
-              <a:t>Aprendizagem por Reforço para Controlo de Enxames · ISCTE-IUL 2026</a:t>
+              <a:t>Aprendizagem por Reforço Multiagente e Neuroevolução · ISCTE-IUL 2026</a:t>
             </a:r>
           </a:p>
         </p:txBody>
@@ -29812,7 +29812,7 @@
                 </a:solidFill>
                 <a:latin typeface="Segoe UI"/>
               </a:rPr>
-              <a:t>Aprendizagem por Reforço para Controlo de Enxames · ISCTE-IUL 2026</a:t>
+              <a:t>Aprendizagem por Reforço Multiagente e Neuroevolução · ISCTE-IUL 2026</a:t>
             </a:r>
           </a:p>
         </p:txBody>
@@ -30402,7 +30402,7 @@
                 </a:solidFill>
                 <a:latin typeface="Segoe UI"/>
               </a:rPr>
-              <a:t>Aprendizagem por Reforço para Controlo de Enxames · ISCTE-IUL 2026</a:t>
+              <a:t>Aprendizagem por Reforço Multiagente e Neuroevolução · ISCTE-IUL 2026</a:t>
             </a:r>
           </a:p>
         </p:txBody>

</xml_diff>

<commit_message>
fix(figuras): o mapa de ocupação do SAC volta a ser reproduzível
O painel do SAC no Muro em U (fig:res_heatmap_ocup) parecia não bater
com o modelo: results/models_sac faz 347 chegadas em 6 episódios, onde a
figura diz 0. O modelo testado estava errado. results/models_sac é de
25 jun, anterior à campanha, e faz mais do que qualquer das 7 execuções
da tese. O modelo da campanha está em results/models_7d, é a execução 7
e dá 0 chegadas, como o eval_by_run_7d.csv. Redesenhado a partir dele
(seeds 2000+ep, escala 2.8): a figura só difere da versão editada à mão
em 16 píxeis por baixo do título. O resultado da tese não muda.

- heatmaps.py: o comentário dizia que os modelos ativos eram os
  campeões 7d; documenta agora quais são e de onde se desenha a figura.
- Slide de reserva A5: «modelos campeões» → «um modelo da campanha por
  algoritmo», e «o SAC nunca o encontra» passa a dizer que é este SAC,
  como 5 das 7 execuções, porque 2 resolvem o Muro em U.
</commit_message>
<xml_diff>
--- a/Defesa/slides_defesa.pptx
+++ b/Defesa/slides_defesa.pptx
@@ -2674,7 +2674,7 @@
           </a:p>
           <a:p>
             <a:r>
-              <a:t>mostra onde o enxame passa o episódio, no modelo campeão de cada algoritmo. O GNN</a:t>
+              <a:t>mostra onde o enxame passa o episódio, num modelo da campanha de cada algoritmo. O GNN</a:t>
             </a:r>
           </a:p>
           <a:p>
@@ -2694,7 +2694,7 @@
           </a:p>
           <a:p>
             <a:r>
-              <a:t>é zero. Não é uma diferença de magnitude, é outro comportamento — e é esta a</a:t>
+              <a:t>é zero — como em cinco das sete execuções do SAC. Não é uma diferença de magnitude, é outro comportamento — e é esta a</a:t>
             </a:r>
           </a:p>
           <a:p>
@@ -24145,7 +24145,7 @@
                 </a:solidFill>
                 <a:latin typeface="Segoe UI"/>
               </a:rPr>
-              <a:t>ocupação média do enxame ao longo do episódio — modelos campeões, 6 episódios cada</a:t>
+              <a:t>ocupação média do enxame ao longo do episódio — um modelo da campanha por algoritmo, 6 episódios cada</a:t>
             </a:r>
           </a:p>
         </p:txBody>
@@ -24587,7 +24587,7 @@
                 </a:solidFill>
                 <a:latin typeface="Segoe UI"/>
               </a:rPr>
-              <a:t>O corredor que contorna o muro é o que separa quem resolve de quem não resolve: o GNN e o PPO desenham-no (476 e 419 chegadas em 6 episódios); o SAC nunca o encontra e faz zero.</a:t>
+              <a:t>O corredor que contorna o muro é o que separa quem resolve de quem não resolve: o GNN e o PPO desenham-no (476 e 419 chegadas em 6 episódios); este SAC, como 5 das suas 7 execuções, nunca o encontra e faz zero.</a:t>
             </a:r>
           </a:p>
         </p:txBody>

</xml_diff>

<commit_message>
fix(tese,defesa): o texto acompanha a validação dos resultados
- SAC no Gargalo (§6.10, §7.5): os dois braços tiveram 48 min; a diferença
  está nos passos (1–6: 8,3–9,4 M, 5/6; 7–21: 2,2–4,0 M, 2/15)
- inferência ~20× (não três ordens de grandeza); percurso ≈122–138 m (não 154)
- Zhang como excluído (E8); §6.2 aponta a Porta Cooperativa
- a robustez deixa de ser atribuída à observação local (tese, artigo, slides)
- hipótese central enunciada na §1.4; §4.5.4 diz «na mesma máquina»
- refs: Ordáz-Rivas vol. 101 (tese e artigo); Iskandar 2026
- verificar_numeros_tese.py acompanha as frases novas
</commit_message>
<xml_diff>
--- a/Defesa/slides_defesa.pptx
+++ b/Defesa/slides_defesa.pptx
@@ -1218,7 +1218,7 @@
           </a:p>
           <a:p>
             <a:r>
-              <a:t>três robôs. A redundância vem da partilha de parâmetros e da observação local.</a:t>
+              <a:t>três robôs. A redundância vem da partilha de parâmetros.</a:t>
             </a:r>
           </a:p>
           <a:p>
@@ -12278,7 +12278,7 @@
                 </a:solidFill>
                 <a:latin typeface="Segoe UI"/>
               </a:rPr>
-              <a:t>Transversal aos paradigmas: a redundância vem do parameter sharing e da observação local — nenhum agente é insubstituível</a:t>
+              <a:t>Transversal aos paradigmas: a redundância vem do parameter sharing — nenhum agente é insubstituível</a:t>
             </a:r>
           </a:p>
           <a:p>

</xml_diff>

<commit_message>
fix(defesa): a cábula e os slides acompanham a tese de 24 set
- cábula: a observação deixa de ser «puramente local» (QI3, §05, §12, glossário);
  o SAC no Gargalo lê-se como sub-treino, não lotaria; pergunta nova sobre a
  réplica 7/21; reprodutibilidade «na mesma máquina», com a reavaliação dos 147
- slides: recuo pendente nos pontos (a 2.ª linha deixa de cair sob o marcador);
  protocolo mais curto; limitações com a perceção global do enxame
- 29 verificadores, 22 no hook (os slides diziam 27/19, a cábula 28/21)
</commit_message>
<xml_diff>
--- a/Defesa/slides_defesa.pptx
+++ b/Defesa/slides_defesa.pptx
@@ -1622,7 +1622,17 @@
           </a:p>
           <a:p>
             <a:r>
-              <a:t>fim do orçamento; o SAC nos gargalos é limite inferior. Tudo é simulação. E a</a:t>
+              <a:t>fim do orçamento; o SAC nos gargalos é limite inferior. A observação do enxame</a:t>
+            </a:r>
+          </a:p>
+          <a:p>
+            <a:r>
+              <a:t>é global: cada robô recebe todos os outros, sem alcance nem paredes — igual para</a:t>
+            </a:r>
+          </a:p>
+          <a:p>
+            <a:r>
+              <a:t>os três, mas não é o que um enxame real teria. Tudo é simulação. E a</a:t>
             </a:r>
           </a:p>
           <a:p>
@@ -7414,32 +7424,73 @@
           </a:bodyPr>
           <a:lstStyle/>
           <a:p>
+            <a:pPr algn="l" marL="254000" indent="-254000">
+              <a:spcAft>
+                <a:spcPts val="800"/>
+              </a:spcAft>
+            </a:pPr>
+            <a:r>
+              <a:rPr sz="1600">
+                <a:solidFill>
+                  <a:srgbClr val="9A9A9A"/>
+                </a:solidFill>
+                <a:latin typeface="Segoe UI"/>
+              </a:rPr>
+              <a:t>▸	</a:t>
+            </a:r>
+            <a:r>
+              <a:rPr sz="1600" b="0">
+                <a:solidFill>
+                  <a:srgbClr val="E2E2E2"/>
+                </a:solidFill>
+                <a:latin typeface="Segoe UI"/>
+              </a:rPr>
+              <a:t>Fitness inicial: chegadas + retorno acumulado do episódio — farmável por deambulação; a população satura num planalto sem pressão seletiva (fitness exploitation)</a:t>
+            </a:r>
+          </a:p>
+          <a:p>
+            <a:pPr algn="l" marL="254000" indent="-254000">
+              <a:spcAft>
+                <a:spcPts val="800"/>
+              </a:spcAft>
+            </a:pPr>
+            <a:r>
+              <a:rPr sz="1600">
+                <a:solidFill>
+                  <a:srgbClr val="9A9A9A"/>
+                </a:solidFill>
+                <a:latin typeface="Segoe UI"/>
+              </a:rPr>
+              <a:t>▸	</a:t>
+            </a:r>
+            <a:r>
+              <a:rPr sz="1600" b="0">
+                <a:solidFill>
+                  <a:srgbClr val="E2E2E2"/>
+                </a:solidFill>
+                <a:latin typeface="Segoe UI"/>
+              </a:rPr>
+              <a:t>Cura: substituir o retorno pelo homing terminal — proximidade ao ninho no fim do episódio, medida no potencial geodésico (contorna paredes; o euclidiano atrai para dentro do beco)</a:t>
+            </a:r>
+          </a:p>
+          <a:p>
             <a:pPr algn="l">
               <a:spcAft>
                 <a:spcPts val="800"/>
               </a:spcAft>
             </a:pPr>
             <a:r>
-              <a:rPr sz="1600">
-                <a:solidFill>
-                  <a:srgbClr val="9A9A9A"/>
+              <a:rPr sz="1600" b="1">
+                <a:solidFill>
+                  <a:srgbClr val="2FB583"/>
                 </a:solidFill>
                 <a:latin typeface="Segoe UI"/>
               </a:rPr>
-              <a:t>▸  </a:t>
-            </a:r>
-            <a:r>
-              <a:rPr sz="1600" b="0">
-                <a:solidFill>
-                  <a:srgbClr val="E2E2E2"/>
-                </a:solidFill>
-                <a:latin typeface="Segoe UI"/>
-              </a:rPr>
-              <a:t>Fitness inicial: chegadas + retorno acumulado do episódio — farmável por deambulação; a população satura num planalto sem pressão seletiva (fitness exploitation)</a:t>
-            </a:r>
-          </a:p>
-          <a:p>
-            <a:pPr algn="l">
+              <a:t>Resultado: de 3 em 12 execuções que chegavam ao ninho para 28 em 28 a 100 % de sucesso.</a:t>
+            </a:r>
+          </a:p>
+          <a:p>
+            <a:pPr algn="l" marL="254000" indent="-254000">
               <a:spcAft>
                 <a:spcPts val="800"/>
               </a:spcAft>
@@ -7451,48 +7502,7 @@
                 </a:solidFill>
                 <a:latin typeface="Segoe UI"/>
               </a:rPr>
-              <a:t>▸  </a:t>
-            </a:r>
-            <a:r>
-              <a:rPr sz="1600" b="0">
-                <a:solidFill>
-                  <a:srgbClr val="E2E2E2"/>
-                </a:solidFill>
-                <a:latin typeface="Segoe UI"/>
-              </a:rPr>
-              <a:t>Cura: substituir o retorno pelo homing terminal — proximidade ao ninho no fim do episódio, medida no potencial geodésico (contorna paredes; o euclidiano atrai para dentro do beco)</a:t>
-            </a:r>
-          </a:p>
-          <a:p>
-            <a:pPr algn="l">
-              <a:spcAft>
-                <a:spcPts val="800"/>
-              </a:spcAft>
-            </a:pPr>
-            <a:r>
-              <a:rPr sz="1600" b="1">
-                <a:solidFill>
-                  <a:srgbClr val="2FB583"/>
-                </a:solidFill>
-                <a:latin typeface="Segoe UI"/>
-              </a:rPr>
-              <a:t>Resultado: de 3 em 12 execuções que chegavam ao ninho para 28 em 28 a 100 % de sucesso.</a:t>
-            </a:r>
-          </a:p>
-          <a:p>
-            <a:pPr algn="l">
-              <a:spcAft>
-                <a:spcPts val="800"/>
-              </a:spcAft>
-            </a:pPr>
-            <a:r>
-              <a:rPr sz="1600">
-                <a:solidFill>
-                  <a:srgbClr val="9A9A9A"/>
-                </a:solidFill>
-                <a:latin typeface="Segoe UI"/>
-              </a:rPr>
-              <a:t>▸  </a:t>
+              <a:t>▸	</a:t>
             </a:r>
             <a:r>
               <a:rPr sz="1600" b="0">
@@ -8902,32 +8912,98 @@
           </a:bodyPr>
           <a:lstStyle/>
           <a:p>
+            <a:pPr algn="l" marL="238125" indent="-238125">
+              <a:spcAft>
+                <a:spcPts val="800"/>
+              </a:spcAft>
+            </a:pPr>
+            <a:r>
+              <a:rPr sz="1500">
+                <a:solidFill>
+                  <a:srgbClr val="9A9A9A"/>
+                </a:solidFill>
+                <a:latin typeface="Segoe UI"/>
+              </a:rPr>
+              <a:t>▸	</a:t>
+            </a:r>
+            <a:r>
+              <a:rPr sz="1500" b="0">
+                <a:solidFill>
+                  <a:srgbClr val="E2E2E2"/>
+                </a:solidFill>
+                <a:latin typeface="Segoe UI"/>
+              </a:rPr>
+              <a:t>Novidade com peso fixo (w = 0,5), orçamento igualado: Muro em U passa de 3/7 para 7/7 (69,8 vs 24,5; p = 0,026, δ = +0,71) — mas custa na Porta com Alternativa (63,0 vs 86,7; δ = −1,00)</a:t>
+            </a:r>
+          </a:p>
+          <a:p>
+            <a:pPr algn="l" marL="238125" indent="-238125">
+              <a:spcAft>
+                <a:spcPts val="800"/>
+              </a:spcAft>
+            </a:pPr>
+            <a:r>
+              <a:rPr sz="1500">
+                <a:solidFill>
+                  <a:srgbClr val="9A9A9A"/>
+                </a:solidFill>
+                <a:latin typeface="Segoe UI"/>
+              </a:rPr>
+              <a:t>▸	</a:t>
+            </a:r>
+            <a:r>
+              <a:rPr sz="1500" b="0">
+                <a:solidFill>
+                  <a:srgbClr val="E2E2E2"/>
+                </a:solidFill>
+                <a:latin typeface="Segoe UI"/>
+              </a:rPr>
+              <a:t>Dosagem adaptativa (pré-registada): w decai após a descoberta sustentada → mantém 7/7 no Muro em U, sem custo significativo em nenhum dos outros seis; com o dobro do orçamento, 88,7 ± 0,6 — o melhor resultado da dissertação</a:t>
+            </a:r>
+          </a:p>
+          <a:p>
+            <a:pPr algn="l" marL="238125" indent="-238125">
+              <a:spcAft>
+                <a:spcPts val="800"/>
+              </a:spcAft>
+            </a:pPr>
+            <a:r>
+              <a:rPr sz="1500">
+                <a:solidFill>
+                  <a:srgbClr val="9A9A9A"/>
+                </a:solidFill>
+                <a:latin typeface="Segoe UI"/>
+              </a:rPr>
+              <a:t>▸	</a:t>
+            </a:r>
+            <a:r>
+              <a:rPr sz="1500" b="0">
+                <a:solidFill>
+                  <a:srgbClr val="E2E2E2"/>
+                </a:solidFill>
+                <a:latin typeface="Segoe UI"/>
+              </a:rPr>
+              <a:t>O ganho não se compra com orçamento: o objetivo puro com 390 min continua bimodal (4/7)</a:t>
+            </a:r>
+          </a:p>
+          <a:p>
             <a:pPr algn="l">
               <a:spcAft>
                 <a:spcPts val="800"/>
               </a:spcAft>
             </a:pPr>
             <a:r>
-              <a:rPr sz="1500">
-                <a:solidFill>
-                  <a:srgbClr val="9A9A9A"/>
+              <a:rPr sz="1500" b="1">
+                <a:solidFill>
+                  <a:srgbClr val="F5F5F5"/>
                 </a:solidFill>
                 <a:latin typeface="Segoe UI"/>
               </a:rPr>
-              <a:t>▸  </a:t>
-            </a:r>
-            <a:r>
-              <a:rPr sz="1500" b="0">
-                <a:solidFill>
-                  <a:srgbClr val="E2E2E2"/>
-                </a:solidFill>
-                <a:latin typeface="Segoe UI"/>
-              </a:rPr>
-              <a:t>Novidade com peso fixo (w = 0,5), orçamento igualado: Muro em U passa de 3/7 para 7/7 (69,8 vs 24,5; p = 0,026, δ = +0,71) — mas custa na Porta com Alternativa (63,0 vs 86,7; δ = −1,00)</a:t>
-            </a:r>
-          </a:p>
-          <a:p>
-            <a:pPr algn="l">
+              <a:t>Replicação a n = 28: 28/28 execuções resolvidas, contra 15/28 do objetivo puro e 14/28 do PPO e do SAC (Fisher exato, p &lt; 0,0001).</a:t>
+            </a:r>
+          </a:p>
+          <a:p>
+            <a:pPr algn="l" marL="238125" indent="-238125">
               <a:spcAft>
                 <a:spcPts val="800"/>
               </a:spcAft>
@@ -8939,73 +9015,7 @@
                 </a:solidFill>
                 <a:latin typeface="Segoe UI"/>
               </a:rPr>
-              <a:t>▸  </a:t>
-            </a:r>
-            <a:r>
-              <a:rPr sz="1500" b="0">
-                <a:solidFill>
-                  <a:srgbClr val="E2E2E2"/>
-                </a:solidFill>
-                <a:latin typeface="Segoe UI"/>
-              </a:rPr>
-              <a:t>Dosagem adaptativa (pré-registada): w decai após a descoberta sustentada → mantém 7/7 no Muro em U, sem custo significativo em nenhum dos outros seis; com o dobro do orçamento, 88,7 ± 0,6 — o melhor resultado da dissertação</a:t>
-            </a:r>
-          </a:p>
-          <a:p>
-            <a:pPr algn="l">
-              <a:spcAft>
-                <a:spcPts val="800"/>
-              </a:spcAft>
-            </a:pPr>
-            <a:r>
-              <a:rPr sz="1500">
-                <a:solidFill>
-                  <a:srgbClr val="9A9A9A"/>
-                </a:solidFill>
-                <a:latin typeface="Segoe UI"/>
-              </a:rPr>
-              <a:t>▸  </a:t>
-            </a:r>
-            <a:r>
-              <a:rPr sz="1500" b="0">
-                <a:solidFill>
-                  <a:srgbClr val="E2E2E2"/>
-                </a:solidFill>
-                <a:latin typeface="Segoe UI"/>
-              </a:rPr>
-              <a:t>O ganho não se compra com orçamento: o objetivo puro com 390 min continua bimodal (4/7)</a:t>
-            </a:r>
-          </a:p>
-          <a:p>
-            <a:pPr algn="l">
-              <a:spcAft>
-                <a:spcPts val="800"/>
-              </a:spcAft>
-            </a:pPr>
-            <a:r>
-              <a:rPr sz="1500" b="1">
-                <a:solidFill>
-                  <a:srgbClr val="F5F5F5"/>
-                </a:solidFill>
-                <a:latin typeface="Segoe UI"/>
-              </a:rPr>
-              <a:t>Replicação a n = 28: 28/28 execuções resolvidas, contra 15/28 do objetivo puro e 14/28 do PPO e do SAC (Fisher exato, p &lt; 0,0001).</a:t>
-            </a:r>
-          </a:p>
-          <a:p>
-            <a:pPr algn="l">
-              <a:spcAft>
-                <a:spcPts val="800"/>
-              </a:spcAft>
-            </a:pPr>
-            <a:r>
-              <a:rPr sz="1500">
-                <a:solidFill>
-                  <a:srgbClr val="9A9A9A"/>
-                </a:solidFill>
-                <a:latin typeface="Segoe UI"/>
-              </a:rPr>
-              <a:t>▸  </a:t>
+              <a:t>▸	</a:t>
             </a:r>
             <a:r>
               <a:rPr sz="1500" b="0">
@@ -9436,7 +9446,7 @@
           </a:bodyPr>
           <a:lstStyle/>
           <a:p>
-            <a:pPr algn="l">
+            <a:pPr algn="l" marL="254000" indent="-254000">
               <a:spcAft>
                 <a:spcPts val="600"/>
               </a:spcAft>
@@ -9448,7 +9458,7 @@
                 </a:solidFill>
                 <a:latin typeface="Segoe UI"/>
               </a:rPr>
-              <a:t>▸  </a:t>
+              <a:t>▸	</a:t>
             </a:r>
             <a:r>
               <a:rPr sz="1600" b="0">
@@ -9461,7 +9471,7 @@
             </a:r>
           </a:p>
           <a:p>
-            <a:pPr algn="l">
+            <a:pPr algn="l" marL="254000" indent="-254000">
               <a:spcAft>
                 <a:spcPts val="600"/>
               </a:spcAft>
@@ -9473,7 +9483,7 @@
                 </a:solidFill>
                 <a:latin typeface="Segoe UI"/>
               </a:rPr>
-              <a:t>▸  </a:t>
+              <a:t>▸	</a:t>
             </a:r>
             <a:r>
               <a:rPr sz="1600" b="0">
@@ -9486,7 +9496,7 @@
             </a:r>
           </a:p>
           <a:p>
-            <a:pPr algn="l">
+            <a:pPr algn="l" marL="254000" indent="-254000">
               <a:spcAft>
                 <a:spcPts val="600"/>
               </a:spcAft>
@@ -9498,7 +9508,7 @@
                 </a:solidFill>
                 <a:latin typeface="Segoe UI"/>
               </a:rPr>
-              <a:t>▸  </a:t>
+              <a:t>▸	</a:t>
             </a:r>
             <a:r>
               <a:rPr sz="1600" b="1">
@@ -12207,7 +12217,7 @@
           </a:bodyPr>
           <a:lstStyle/>
           <a:p>
-            <a:pPr algn="l">
+            <a:pPr algn="l" marL="269875" indent="-269875">
               <a:spcAft>
                 <a:spcPts val="800"/>
               </a:spcAft>
@@ -12219,7 +12229,7 @@
                 </a:solidFill>
                 <a:latin typeface="Segoe UI"/>
               </a:rPr>
-              <a:t>▸  </a:t>
+              <a:t>▸	</a:t>
             </a:r>
             <a:r>
               <a:rPr sz="1700" b="0">
@@ -12232,7 +12242,7 @@
             </a:r>
           </a:p>
           <a:p>
-            <a:pPr algn="l">
+            <a:pPr algn="l" marL="269875" indent="-269875">
               <a:spcAft>
                 <a:spcPts val="800"/>
               </a:spcAft>
@@ -12244,7 +12254,7 @@
                 </a:solidFill>
                 <a:latin typeface="Segoe UI"/>
               </a:rPr>
-              <a:t>▸  </a:t>
+              <a:t>▸	</a:t>
             </a:r>
             <a:r>
               <a:rPr sz="1700" b="0">
@@ -12257,7 +12267,7 @@
             </a:r>
           </a:p>
           <a:p>
-            <a:pPr algn="l">
+            <a:pPr algn="l" marL="269875" indent="-269875">
               <a:spcAft>
                 <a:spcPts val="800"/>
               </a:spcAft>
@@ -12269,7 +12279,7 @@
                 </a:solidFill>
                 <a:latin typeface="Segoe UI"/>
               </a:rPr>
-              <a:t>▸  </a:t>
+              <a:t>▸	</a:t>
             </a:r>
             <a:r>
               <a:rPr sz="1700" b="0">
@@ -12282,7 +12292,7 @@
             </a:r>
           </a:p>
           <a:p>
-            <a:pPr algn="l">
+            <a:pPr algn="l" marL="269875" indent="-269875">
               <a:spcAft>
                 <a:spcPts val="800"/>
               </a:spcAft>
@@ -12294,7 +12304,7 @@
                 </a:solidFill>
                 <a:latin typeface="Segoe UI"/>
               </a:rPr>
-              <a:t>▸  </a:t>
+              <a:t>▸	</a:t>
             </a:r>
             <a:r>
               <a:rPr sz="1700" b="0">
@@ -13097,7 +13107,7 @@
           </a:bodyPr>
           <a:lstStyle/>
           <a:p>
-            <a:pPr algn="l">
+            <a:pPr algn="l" marL="238125" indent="-238125">
               <a:spcAft>
                 <a:spcPts val="600"/>
               </a:spcAft>
@@ -13109,7 +13119,7 @@
                 </a:solidFill>
                 <a:latin typeface="Segoe UI"/>
               </a:rPr>
-              <a:t>▸  </a:t>
+              <a:t>▸	</a:t>
             </a:r>
             <a:r>
               <a:rPr sz="1500" b="0">
@@ -13122,7 +13132,7 @@
             </a:r>
           </a:p>
           <a:p>
-            <a:pPr algn="l">
+            <a:pPr algn="l" marL="238125" indent="-238125">
               <a:spcAft>
                 <a:spcPts val="600"/>
               </a:spcAft>
@@ -13134,7 +13144,7 @@
                 </a:solidFill>
                 <a:latin typeface="Segoe UI"/>
               </a:rPr>
-              <a:t>▸  </a:t>
+              <a:t>▸	</a:t>
             </a:r>
             <a:r>
               <a:rPr sz="1500" b="0">
@@ -14735,7 +14745,7 @@
           </a:bodyPr>
           <a:lstStyle/>
           <a:p>
-            <a:pPr algn="l">
+            <a:pPr algn="l" marL="238125" indent="-238125">
               <a:spcAft>
                 <a:spcPts val="800"/>
               </a:spcAft>
@@ -14747,7 +14757,7 @@
                 </a:solidFill>
                 <a:latin typeface="Segoe UI"/>
               </a:rPr>
-              <a:t>▸  </a:t>
+              <a:t>▸	</a:t>
             </a:r>
             <a:r>
               <a:rPr sz="1500" b="0">
@@ -14760,7 +14770,7 @@
             </a:r>
           </a:p>
           <a:p>
-            <a:pPr algn="l">
+            <a:pPr algn="l" marL="238125" indent="-238125">
               <a:spcAft>
                 <a:spcPts val="800"/>
               </a:spcAft>
@@ -14772,7 +14782,7 @@
                 </a:solidFill>
                 <a:latin typeface="Segoe UI"/>
               </a:rPr>
-              <a:t>▸  </a:t>
+              <a:t>▸	</a:t>
             </a:r>
             <a:r>
               <a:rPr sz="1500" b="0">
@@ -14785,7 +14795,7 @@
             </a:r>
           </a:p>
           <a:p>
-            <a:pPr algn="l">
+            <a:pPr algn="l" marL="238125" indent="-238125">
               <a:spcAft>
                 <a:spcPts val="800"/>
               </a:spcAft>
@@ -14797,7 +14807,7 @@
                 </a:solidFill>
                 <a:latin typeface="Segoe UI"/>
               </a:rPr>
-              <a:t>▸  </a:t>
+              <a:t>▸	</a:t>
             </a:r>
             <a:r>
               <a:rPr sz="1500" b="0">
@@ -14810,7 +14820,7 @@
             </a:r>
           </a:p>
           <a:p>
-            <a:pPr algn="l">
+            <a:pPr algn="l" marL="238125" indent="-238125">
               <a:spcAft>
                 <a:spcPts val="800"/>
               </a:spcAft>
@@ -14822,7 +14832,7 @@
                 </a:solidFill>
                 <a:latin typeface="Segoe UI"/>
               </a:rPr>
-              <a:t>▸  </a:t>
+              <a:t>▸	</a:t>
             </a:r>
             <a:r>
               <a:rPr sz="1500" b="0">
@@ -14831,11 +14841,11 @@
                 </a:solidFill>
                 <a:latin typeface="Segoe UI"/>
               </a:rPr>
-              <a:t>Só simulação: o fosso de implantação fica por validar</a:t>
-            </a:r>
-          </a:p>
-          <a:p>
-            <a:pPr algn="l">
+              <a:t>Perceção do enxame global: cada robô vê todos os outros, sem alcance nem oclusão (igual nos três; local é só o LiDAR)</a:t>
+            </a:r>
+          </a:p>
+          <a:p>
+            <a:pPr algn="l" marL="238125" indent="-238125">
               <a:spcAft>
                 <a:spcPts val="800"/>
               </a:spcAft>
@@ -14847,7 +14857,7 @@
                 </a:solidFill>
                 <a:latin typeface="Segoe UI"/>
               </a:rPr>
-              <a:t>▸  </a:t>
+              <a:t>▸	</a:t>
             </a:r>
             <a:r>
               <a:rPr sz="1500" b="0">
@@ -14856,11 +14866,11 @@
                 </a:solidFill>
                 <a:latin typeface="Segoe UI"/>
               </a:rPr>
-              <a:t>Dimensão vertical usada mas não observada; duas costuras na física das paredes — 11 de 343 modelos arquivados atravessam-nas, todos do evolutivo; na campanha final são 3 de 70 (Quatro Salas), e não as tornam melhores (55,7 vs 60,3 chegadas/ep). Onde a costura pesa é numa célula da campanha adaptativa — Quatro Salas —, declarada como contaminada</a:t>
-            </a:r>
-          </a:p>
-          <a:p>
-            <a:pPr algn="l">
+              <a:t>Só simulação: o fosso de implantação fica por validar</a:t>
+            </a:r>
+          </a:p>
+          <a:p>
+            <a:pPr algn="l" marL="238125" indent="-238125">
               <a:spcAft>
                 <a:spcPts val="800"/>
               </a:spcAft>
@@ -14872,7 +14882,32 @@
                 </a:solidFill>
                 <a:latin typeface="Segoe UI"/>
               </a:rPr>
-              <a:t>▸  </a:t>
+              <a:t>▸	</a:t>
+            </a:r>
+            <a:r>
+              <a:rPr sz="1500" b="0">
+                <a:solidFill>
+                  <a:srgbClr val="E2E2E2"/>
+                </a:solidFill>
+                <a:latin typeface="Segoe UI"/>
+              </a:rPr>
+              <a:t>Física: altitude usada mas não observada; costuras nas paredes — 3 de 70 modelos da campanha final, sem ficarem melhores (55,7 vs 60,3)</a:t>
+            </a:r>
+          </a:p>
+          <a:p>
+            <a:pPr algn="l" marL="238125" indent="-238125">
+              <a:spcAft>
+                <a:spcPts val="800"/>
+              </a:spcAft>
+            </a:pPr>
+            <a:r>
+              <a:rPr sz="1500">
+                <a:solidFill>
+                  <a:srgbClr val="9A9A9A"/>
+                </a:solidFill>
+                <a:latin typeface="Segoe UI"/>
+              </a:rPr>
+              <a:t>▸	</a:t>
             </a:r>
             <a:r>
               <a:rPr sz="1500" b="0">
@@ -15388,7 +15423,7 @@
                 </a:solidFill>
                 <a:latin typeface="Segoe UI"/>
               </a:rPr>
-              <a:t>  simulador, oito cenários, RS2C e neuroevolução; 27 verificadores ligam cada número aos dados</a:t>
+              <a:t>  simulador, oito cenários, RS2C e neuroevolução; 29 verificadores ligam cada número aos dados</a:t>
             </a:r>
           </a:p>
         </p:txBody>
@@ -20199,7 +20234,7 @@
           </a:bodyPr>
           <a:lstStyle/>
           <a:p>
-            <a:pPr algn="l">
+            <a:pPr algn="l" marL="254000" indent="-254000">
               <a:spcAft>
                 <a:spcPts val="600"/>
               </a:spcAft>
@@ -20211,7 +20246,7 @@
                 </a:solidFill>
                 <a:latin typeface="Segoe UI"/>
               </a:rPr>
-              <a:t>▸  </a:t>
+              <a:t>▸	</a:t>
             </a:r>
             <a:r>
               <a:rPr sz="1600" b="0">
@@ -20224,7 +20259,7 @@
             </a:r>
           </a:p>
           <a:p>
-            <a:pPr algn="l">
+            <a:pPr algn="l" marL="254000" indent="-254000">
               <a:spcAft>
                 <a:spcPts val="600"/>
               </a:spcAft>
@@ -20236,7 +20271,7 @@
                 </a:solidFill>
                 <a:latin typeface="Segoe UI"/>
               </a:rPr>
-              <a:t>▸  </a:t>
+              <a:t>▸	</a:t>
             </a:r>
             <a:r>
               <a:rPr sz="1600" b="0">
@@ -20249,7 +20284,7 @@
             </a:r>
           </a:p>
           <a:p>
-            <a:pPr algn="l">
+            <a:pPr algn="l" marL="254000" indent="-254000">
               <a:spcAft>
                 <a:spcPts val="600"/>
               </a:spcAft>
@@ -20261,7 +20296,7 @@
                 </a:solidFill>
                 <a:latin typeface="Segoe UI"/>
               </a:rPr>
-              <a:t>▸  </a:t>
+              <a:t>▸	</a:t>
             </a:r>
             <a:r>
               <a:rPr sz="1600" b="0">
@@ -23077,7 +23112,7 @@
           </a:bodyPr>
           <a:lstStyle/>
           <a:p>
-            <a:pPr algn="l">
+            <a:pPr algn="l" marL="254000" indent="-254000">
               <a:spcAft>
                 <a:spcPts val="600"/>
               </a:spcAft>
@@ -23089,7 +23124,7 @@
                 </a:solidFill>
                 <a:latin typeface="Segoe UI"/>
               </a:rPr>
-              <a:t>▸  </a:t>
+              <a:t>▸	</a:t>
             </a:r>
             <a:r>
               <a:rPr sz="1600" b="0">
@@ -23102,7 +23137,7 @@
             </a:r>
           </a:p>
           <a:p>
-            <a:pPr algn="l">
+            <a:pPr algn="l" marL="254000" indent="-254000">
               <a:spcAft>
                 <a:spcPts val="600"/>
               </a:spcAft>
@@ -23114,7 +23149,7 @@
                 </a:solidFill>
                 <a:latin typeface="Segoe UI"/>
               </a:rPr>
-              <a:t>▸  </a:t>
+              <a:t>▸	</a:t>
             </a:r>
             <a:r>
               <a:rPr sz="1600" b="0">
@@ -23127,7 +23162,7 @@
             </a:r>
           </a:p>
           <a:p>
-            <a:pPr algn="l">
+            <a:pPr algn="l" marL="254000" indent="-254000">
               <a:spcAft>
                 <a:spcPts val="600"/>
               </a:spcAft>
@@ -23139,7 +23174,7 @@
                 </a:solidFill>
                 <a:latin typeface="Segoe UI"/>
               </a:rPr>
-              <a:t>▸  </a:t>
+              <a:t>▸	</a:t>
             </a:r>
             <a:r>
               <a:rPr sz="1600" b="0">
@@ -24947,7 +24982,7 @@
           </a:bodyPr>
           <a:lstStyle/>
           <a:p>
-            <a:pPr algn="l">
+            <a:pPr algn="l" marL="254000" indent="-254000">
               <a:spcAft>
                 <a:spcPts val="800"/>
               </a:spcAft>
@@ -24959,7 +24994,7 @@
                 </a:solidFill>
                 <a:latin typeface="Segoe UI"/>
               </a:rPr>
-              <a:t>▸  </a:t>
+              <a:t>▸	</a:t>
             </a:r>
             <a:r>
               <a:rPr sz="1600" b="0">
@@ -24968,11 +25003,11 @@
                 </a:solidFill>
                 <a:latin typeface="Segoe UI"/>
               </a:rPr>
-              <a:t>27 verificadores automáticos; 19 correm no hook de pre-commit e recusam o commit se um número da tese deixar de bater com o CSV que o produziu</a:t>
-            </a:r>
-          </a:p>
-          <a:p>
-            <a:pPr algn="l">
+              <a:t>29 verificadores automáticos; 22 correm no hook de pre-commit e recusam o commit se um número da tese deixar de bater com o CSV que o produziu</a:t>
+            </a:r>
+          </a:p>
+          <a:p>
+            <a:pPr algn="l" marL="254000" indent="-254000">
               <a:spcAft>
                 <a:spcPts val="800"/>
               </a:spcAft>
@@ -24984,7 +25019,7 @@
                 </a:solidFill>
                 <a:latin typeface="Segoe UI"/>
               </a:rPr>
-              <a:t>▸  </a:t>
+              <a:t>▸	</a:t>
             </a:r>
             <a:r>
               <a:rPr sz="1600" b="0">
@@ -24997,7 +25032,7 @@
             </a:r>
           </a:p>
           <a:p>
-            <a:pPr algn="l">
+            <a:pPr algn="l" marL="254000" indent="-254000">
               <a:spcAft>
                 <a:spcPts val="800"/>
               </a:spcAft>
@@ -25009,7 +25044,7 @@
                 </a:solidFill>
                 <a:latin typeface="Segoe UI"/>
               </a:rPr>
-              <a:t>▸  </a:t>
+              <a:t>▸	</a:t>
             </a:r>
             <a:r>
               <a:rPr sz="1600" b="0">
@@ -25022,7 +25057,7 @@
             </a:r>
           </a:p>
           <a:p>
-            <a:pPr algn="l">
+            <a:pPr algn="l" marL="254000" indent="-254000">
               <a:spcAft>
                 <a:spcPts val="800"/>
               </a:spcAft>
@@ -25034,7 +25069,7 @@
                 </a:solidFill>
                 <a:latin typeface="Segoe UI"/>
               </a:rPr>
-              <a:t>▸  </a:t>
+              <a:t>▸	</a:t>
             </a:r>
             <a:r>
               <a:rPr sz="1600" b="0">
@@ -25047,7 +25082,7 @@
             </a:r>
           </a:p>
           <a:p>
-            <a:pPr algn="l">
+            <a:pPr algn="l" marL="254000" indent="-254000">
               <a:spcAft>
                 <a:spcPts val="800"/>
               </a:spcAft>
@@ -25059,7 +25094,7 @@
                 </a:solidFill>
                 <a:latin typeface="Segoe UI"/>
               </a:rPr>
-              <a:t>▸  </a:t>
+              <a:t>▸	</a:t>
             </a:r>
             <a:r>
               <a:rPr sz="1600" b="0">
@@ -25072,7 +25107,7 @@
             </a:r>
           </a:p>
           <a:p>
-            <a:pPr algn="l">
+            <a:pPr algn="l" marL="254000" indent="-254000">
               <a:spcAft>
                 <a:spcPts val="800"/>
               </a:spcAft>
@@ -25084,7 +25119,7 @@
                 </a:solidFill>
                 <a:latin typeface="Segoe UI"/>
               </a:rPr>
-              <a:t>▸  </a:t>
+              <a:t>▸	</a:t>
             </a:r>
             <a:r>
               <a:rPr sz="1600" b="0">
@@ -25443,7 +25478,7 @@
           </a:bodyPr>
           <a:lstStyle/>
           <a:p>
-            <a:pPr algn="l">
+            <a:pPr algn="l" marL="269875" indent="-269875">
               <a:spcAft>
                 <a:spcPts val="800"/>
               </a:spcAft>
@@ -25455,7 +25490,7 @@
                 </a:solidFill>
                 <a:latin typeface="Segoe UI"/>
               </a:rPr>
-              <a:t>▸  </a:t>
+              <a:t>▸	</a:t>
             </a:r>
             <a:r>
               <a:rPr sz="1700" b="0">
@@ -25468,7 +25503,7 @@
             </a:r>
           </a:p>
           <a:p>
-            <a:pPr algn="l">
+            <a:pPr algn="l" marL="269875" indent="-269875">
               <a:spcAft>
                 <a:spcPts val="800"/>
               </a:spcAft>
@@ -25480,7 +25515,7 @@
                 </a:solidFill>
                 <a:latin typeface="Segoe UI"/>
               </a:rPr>
-              <a:t>▸  </a:t>
+              <a:t>▸	</a:t>
             </a:r>
             <a:r>
               <a:rPr sz="1700" b="0">
@@ -25525,7 +25560,7 @@
             </a:r>
           </a:p>
           <a:p>
-            <a:pPr algn="l">
+            <a:pPr algn="l" marL="269875" indent="-269875">
               <a:spcAft>
                 <a:spcPts val="800"/>
               </a:spcAft>
@@ -25537,7 +25572,7 @@
                 </a:solidFill>
                 <a:latin typeface="Segoe UI"/>
               </a:rPr>
-              <a:t>▸  </a:t>
+              <a:t>▸	</a:t>
             </a:r>
             <a:r>
               <a:rPr sz="1700" b="0">
@@ -25550,7 +25585,7 @@
             </a:r>
           </a:p>
           <a:p>
-            <a:pPr algn="l">
+            <a:pPr algn="l" marL="269875" indent="-269875">
               <a:spcAft>
                 <a:spcPts val="800"/>
               </a:spcAft>
@@ -25562,7 +25597,7 @@
                 </a:solidFill>
                 <a:latin typeface="Segoe UI"/>
               </a:rPr>
-              <a:t>▸  </a:t>
+              <a:t>▸	</a:t>
             </a:r>
             <a:r>
               <a:rPr sz="1700" b="0">
@@ -26025,32 +26060,123 @@
             </a:r>
           </a:p>
           <a:p>
+            <a:pPr algn="l" marL="269875" indent="-269875">
+              <a:spcAft>
+                <a:spcPts val="800"/>
+              </a:spcAft>
+            </a:pPr>
+            <a:r>
+              <a:rPr sz="1700">
+                <a:solidFill>
+                  <a:srgbClr val="9A9A9A"/>
+                </a:solidFill>
+                <a:latin typeface="Segoe UI"/>
+              </a:rPr>
+              <a:t>▸	</a:t>
+            </a:r>
+            <a:r>
+              <a:rPr sz="1700" b="0">
+                <a:solidFill>
+                  <a:srgbClr val="E2E2E2"/>
+                </a:solidFill>
+                <a:latin typeface="Segoe UI"/>
+              </a:rPr>
+              <a:t>QI1  Desempenho de tarefa: qual paradigma é mais eficaz, e em que cenários?</a:t>
+            </a:r>
+          </a:p>
+          <a:p>
+            <a:pPr algn="l" marL="269875" indent="-269875">
+              <a:spcAft>
+                <a:spcPts val="800"/>
+              </a:spcAft>
+            </a:pPr>
+            <a:r>
+              <a:rPr sz="1700">
+                <a:solidFill>
+                  <a:srgbClr val="9A9A9A"/>
+                </a:solidFill>
+                <a:latin typeface="Segoe UI"/>
+              </a:rPr>
+              <a:t>▸	</a:t>
+            </a:r>
+            <a:r>
+              <a:rPr sz="1700" b="0">
+                <a:solidFill>
+                  <a:srgbClr val="E2E2E2"/>
+                </a:solidFill>
+                <a:latin typeface="Segoe UI"/>
+              </a:rPr>
+              <a:t>QI2  Escalabilidade: uma política treinada com N=20 transfere-se para N=10…100 sem retreino?</a:t>
+            </a:r>
+          </a:p>
+          <a:p>
+            <a:pPr algn="l" marL="269875" indent="-269875">
+              <a:spcAft>
+                <a:spcPts val="800"/>
+              </a:spcAft>
+            </a:pPr>
+            <a:r>
+              <a:rPr sz="1700">
+                <a:solidFill>
+                  <a:srgbClr val="9A9A9A"/>
+                </a:solidFill>
+                <a:latin typeface="Segoe UI"/>
+              </a:rPr>
+              <a:t>▸	</a:t>
+            </a:r>
+            <a:r>
+              <a:rPr sz="1700" b="0">
+                <a:solidFill>
+                  <a:srgbClr val="E2E2E2"/>
+                </a:solidFill>
+                <a:latin typeface="Segoe UI"/>
+              </a:rPr>
+              <a:t>QI3  Robustez: o que acontece quando 10 % dos agentes falham a meio?</a:t>
+            </a:r>
+          </a:p>
+          <a:p>
+            <a:pPr algn="l" marL="269875" indent="-269875">
+              <a:spcAft>
+                <a:spcPts val="800"/>
+              </a:spcAft>
+            </a:pPr>
+            <a:r>
+              <a:rPr sz="1700">
+                <a:solidFill>
+                  <a:srgbClr val="9A9A9A"/>
+                </a:solidFill>
+                <a:latin typeface="Segoe UI"/>
+              </a:rPr>
+              <a:t>▸	</a:t>
+            </a:r>
+            <a:r>
+              <a:rPr sz="1700" b="0">
+                <a:solidFill>
+                  <a:srgbClr val="E2E2E2"/>
+                </a:solidFill>
+                <a:latin typeface="Segoe UI"/>
+              </a:rPr>
+              <a:t>QI4  Critério de escolha: quando preferir um ao outro?</a:t>
+            </a:r>
+          </a:p>
+          <a:p>
             <a:pPr algn="l">
               <a:spcAft>
                 <a:spcPts val="800"/>
               </a:spcAft>
             </a:pPr>
             <a:r>
-              <a:rPr sz="1700">
-                <a:solidFill>
-                  <a:srgbClr val="9A9A9A"/>
+              <a:rPr sz="1700" b="1">
+                <a:solidFill>
+                  <a:srgbClr val="F5F5F5"/>
                 </a:solidFill>
                 <a:latin typeface="Segoe UI"/>
               </a:rPr>
-              <a:t>▸  </a:t>
-            </a:r>
-            <a:r>
-              <a:rPr sz="1700" b="0">
-                <a:solidFill>
-                  <a:srgbClr val="E2E2E2"/>
-                </a:solidFill>
-                <a:latin typeface="Segoe UI"/>
-              </a:rPr>
-              <a:t>QI1  Desempenho de tarefa: qual paradigma é mais eficaz, e em que cenários?</a:t>
-            </a:r>
-          </a:p>
-          <a:p>
-            <a:pPr algn="l">
+              <a:t>Nível 2 — mecanismos</a:t>
+            </a:r>
+          </a:p>
+          <a:p>
+            <a:pPr algn="l" marL="269875" indent="-269875">
               <a:spcAft>
                 <a:spcPts val="800"/>
               </a:spcAft>
@@ -26062,7 +26188,7 @@
                 </a:solidFill>
                 <a:latin typeface="Segoe UI"/>
               </a:rPr>
-              <a:t>▸  </a:t>
+              <a:t>▸	</a:t>
             </a:r>
             <a:r>
               <a:rPr sz="1700" b="0">
@@ -26071,11 +26197,11 @@
                 </a:solidFill>
                 <a:latin typeface="Segoe UI"/>
               </a:rPr>
-              <a:t>QI2  Escalabilidade: uma política treinada com N=20 transfere-se para N=10…100 sem retreino?</a:t>
-            </a:r>
-          </a:p>
-          <a:p>
-            <a:pPr algn="l">
+              <a:t>QI5  Desenho da fitness: um shaping de homing desbloqueia o que a fitness pura não resolve?</a:t>
+            </a:r>
+          </a:p>
+          <a:p>
+            <a:pPr algn="l" marL="269875" indent="-269875">
               <a:spcAft>
                 <a:spcPts val="800"/>
               </a:spcAft>
@@ -26087,7 +26213,7 @@
                 </a:solidFill>
                 <a:latin typeface="Segoe UI"/>
               </a:rPr>
-              <a:t>▸  </a:t>
+              <a:t>▸	</a:t>
             </a:r>
             <a:r>
               <a:rPr sz="1700" b="0">
@@ -26096,11 +26222,11 @@
                 </a:solidFill>
                 <a:latin typeface="Segoe UI"/>
               </a:rPr>
-              <a:t>QI3  Robustez: o que acontece quando 10 % dos agentes falham a meio?</a:t>
-            </a:r>
-          </a:p>
-          <a:p>
-            <a:pPr algn="l">
+              <a:t>QI6  Deceção: a procura por novidade ajuda onde o gradiente engana?</a:t>
+            </a:r>
+          </a:p>
+          <a:p>
+            <a:pPr algn="l" marL="269875" indent="-269875">
               <a:spcAft>
                 <a:spcPts val="800"/>
               </a:spcAft>
@@ -26112,98 +26238,7 @@
                 </a:solidFill>
                 <a:latin typeface="Segoe UI"/>
               </a:rPr>
-              <a:t>▸  </a:t>
-            </a:r>
-            <a:r>
-              <a:rPr sz="1700" b="0">
-                <a:solidFill>
-                  <a:srgbClr val="E2E2E2"/>
-                </a:solidFill>
-                <a:latin typeface="Segoe UI"/>
-              </a:rPr>
-              <a:t>QI4  Critério de escolha: quando preferir um ao outro?</a:t>
-            </a:r>
-          </a:p>
-          <a:p>
-            <a:pPr algn="l">
-              <a:spcAft>
-                <a:spcPts val="800"/>
-              </a:spcAft>
-            </a:pPr>
-            <a:r>
-              <a:rPr sz="1700" b="1">
-                <a:solidFill>
-                  <a:srgbClr val="F5F5F5"/>
-                </a:solidFill>
-                <a:latin typeface="Segoe UI"/>
-              </a:rPr>
-              <a:t>Nível 2 — mecanismos</a:t>
-            </a:r>
-          </a:p>
-          <a:p>
-            <a:pPr algn="l">
-              <a:spcAft>
-                <a:spcPts val="800"/>
-              </a:spcAft>
-            </a:pPr>
-            <a:r>
-              <a:rPr sz="1700">
-                <a:solidFill>
-                  <a:srgbClr val="9A9A9A"/>
-                </a:solidFill>
-                <a:latin typeface="Segoe UI"/>
-              </a:rPr>
-              <a:t>▸  </a:t>
-            </a:r>
-            <a:r>
-              <a:rPr sz="1700" b="0">
-                <a:solidFill>
-                  <a:srgbClr val="E2E2E2"/>
-                </a:solidFill>
-                <a:latin typeface="Segoe UI"/>
-              </a:rPr>
-              <a:t>QI5  Desenho da fitness: um shaping de homing desbloqueia o que a fitness pura não resolve?</a:t>
-            </a:r>
-          </a:p>
-          <a:p>
-            <a:pPr algn="l">
-              <a:spcAft>
-                <a:spcPts val="800"/>
-              </a:spcAft>
-            </a:pPr>
-            <a:r>
-              <a:rPr sz="1700">
-                <a:solidFill>
-                  <a:srgbClr val="9A9A9A"/>
-                </a:solidFill>
-                <a:latin typeface="Segoe UI"/>
-              </a:rPr>
-              <a:t>▸  </a:t>
-            </a:r>
-            <a:r>
-              <a:rPr sz="1700" b="0">
-                <a:solidFill>
-                  <a:srgbClr val="E2E2E2"/>
-                </a:solidFill>
-                <a:latin typeface="Segoe UI"/>
-              </a:rPr>
-              <a:t>QI6  Deceção: a procura por novidade ajuda onde o gradiente engana?</a:t>
-            </a:r>
-          </a:p>
-          <a:p>
-            <a:pPr algn="l">
-              <a:spcAft>
-                <a:spcPts val="800"/>
-              </a:spcAft>
-            </a:pPr>
-            <a:r>
-              <a:rPr sz="1700">
-                <a:solidFill>
-                  <a:srgbClr val="9A9A9A"/>
-                </a:solidFill>
-                <a:latin typeface="Segoe UI"/>
-              </a:rPr>
-              <a:t>▸  </a:t>
+              <a:t>▸	</a:t>
             </a:r>
             <a:r>
               <a:rPr sz="1700" b="0">
@@ -26562,7 +26597,7 @@
           </a:bodyPr>
           <a:lstStyle/>
           <a:p>
-            <a:pPr algn="l">
+            <a:pPr algn="l" marL="254000" indent="-254000">
               <a:spcAft>
                 <a:spcPts val="800"/>
               </a:spcAft>
@@ -26574,7 +26609,7 @@
                 </a:solidFill>
                 <a:latin typeface="Segoe UI"/>
               </a:rPr>
-              <a:t>▸  </a:t>
+              <a:t>▸	</a:t>
             </a:r>
             <a:r>
               <a:rPr sz="1600" b="0">
@@ -26587,7 +26622,7 @@
             </a:r>
           </a:p>
           <a:p>
-            <a:pPr algn="l">
+            <a:pPr algn="l" marL="254000" indent="-254000">
               <a:spcAft>
                 <a:spcPts val="800"/>
               </a:spcAft>
@@ -26599,7 +26634,7 @@
                 </a:solidFill>
                 <a:latin typeface="Segoe UI"/>
               </a:rPr>
-              <a:t>▸  </a:t>
+              <a:t>▸	</a:t>
             </a:r>
             <a:r>
               <a:rPr sz="1600" b="0">
@@ -26612,7 +26647,7 @@
             </a:r>
           </a:p>
           <a:p>
-            <a:pPr algn="l">
+            <a:pPr algn="l" marL="254000" indent="-254000">
               <a:spcAft>
                 <a:spcPts val="800"/>
               </a:spcAft>
@@ -26624,7 +26659,7 @@
                 </a:solidFill>
                 <a:latin typeface="Segoe UI"/>
               </a:rPr>
-              <a:t>▸  </a:t>
+              <a:t>▸	</a:t>
             </a:r>
             <a:r>
               <a:rPr sz="1600" b="0">
@@ -26669,7 +26704,7 @@
             </a:r>
           </a:p>
           <a:p>
-            <a:pPr algn="l">
+            <a:pPr algn="l" marL="254000" indent="-254000">
               <a:spcAft>
                 <a:spcPts val="800"/>
               </a:spcAft>
@@ -26681,7 +26716,7 @@
                 </a:solidFill>
                 <a:latin typeface="Segoe UI"/>
               </a:rPr>
-              <a:t>▸  </a:t>
+              <a:t>▸	</a:t>
             </a:r>
             <a:r>
               <a:rPr sz="1600" b="0">
@@ -26694,7 +26729,7 @@
             </a:r>
           </a:p>
           <a:p>
-            <a:pPr algn="l">
+            <a:pPr algn="l" marL="254000" indent="-254000">
               <a:spcAft>
                 <a:spcPts val="800"/>
               </a:spcAft>
@@ -26706,7 +26741,7 @@
                 </a:solidFill>
                 <a:latin typeface="Segoe UI"/>
               </a:rPr>
-              <a:t>▸  </a:t>
+              <a:t>▸	</a:t>
             </a:r>
             <a:r>
               <a:rPr sz="1600" b="0">
@@ -28903,7 +28938,7 @@
           </a:bodyPr>
           <a:lstStyle/>
           <a:p>
-            <a:pPr algn="l">
+            <a:pPr algn="l" marL="269875" indent="-269875">
               <a:spcAft>
                 <a:spcPts val="800"/>
               </a:spcAft>
@@ -28915,7 +28950,7 @@
                 </a:solidFill>
                 <a:latin typeface="Segoe UI"/>
               </a:rPr>
-              <a:t>▸  </a:t>
+              <a:t>▸	</a:t>
             </a:r>
             <a:r>
               <a:rPr sz="1700" b="0">
@@ -28928,7 +28963,7 @@
             </a:r>
           </a:p>
           <a:p>
-            <a:pPr algn="l">
+            <a:pPr algn="l" marL="269875" indent="-269875">
               <a:spcAft>
                 <a:spcPts val="800"/>
               </a:spcAft>
@@ -28940,7 +28975,7 @@
                 </a:solidFill>
                 <a:latin typeface="Segoe UI"/>
               </a:rPr>
-              <a:t>▸  </a:t>
+              <a:t>▸	</a:t>
             </a:r>
             <a:r>
               <a:rPr sz="1700" b="0">
@@ -28953,7 +28988,7 @@
             </a:r>
           </a:p>
           <a:p>
-            <a:pPr algn="l">
+            <a:pPr algn="l" marL="269875" indent="-269875">
               <a:spcAft>
                 <a:spcPts val="800"/>
               </a:spcAft>
@@ -28965,7 +29000,7 @@
                 </a:solidFill>
                 <a:latin typeface="Segoe UI"/>
               </a:rPr>
-              <a:t>▸  </a:t>
+              <a:t>▸	</a:t>
             </a:r>
             <a:r>
               <a:rPr sz="1700" b="0">
@@ -28978,7 +29013,7 @@
             </a:r>
           </a:p>
           <a:p>
-            <a:pPr algn="l">
+            <a:pPr algn="l" marL="269875" indent="-269875">
               <a:spcAft>
                 <a:spcPts val="800"/>
               </a:spcAft>
@@ -28990,7 +29025,7 @@
                 </a:solidFill>
                 <a:latin typeface="Segoe UI"/>
               </a:rPr>
-              <a:t>▸  </a:t>
+              <a:t>▸	</a:t>
             </a:r>
             <a:r>
               <a:rPr sz="1700" b="0">
@@ -29003,7 +29038,7 @@
             </a:r>
           </a:p>
           <a:p>
-            <a:pPr algn="l">
+            <a:pPr algn="l" marL="269875" indent="-269875">
               <a:spcAft>
                 <a:spcPts val="800"/>
               </a:spcAft>
@@ -29015,7 +29050,7 @@
                 </a:solidFill>
                 <a:latin typeface="Segoe UI"/>
               </a:rPr>
-              <a:t>▸  </a:t>
+              <a:t>▸	</a:t>
             </a:r>
             <a:r>
               <a:rPr sz="1700" b="0">
@@ -29024,11 +29059,11 @@
                 </a:solidFill>
                 <a:latin typeface="Segoe UI"/>
               </a:rPr>
-              <a:t>Três campanhas pré-registadas (hipótese, testes e regra de decisão fixados antes dos dados)</a:t>
-            </a:r>
-          </a:p>
-          <a:p>
-            <a:pPr algn="l">
+              <a:t>Três campanhas pré-registadas: hipótese, testes e regra de decisão antes dos dados</a:t>
+            </a:r>
+          </a:p>
+          <a:p>
+            <a:pPr algn="l" marL="269875" indent="-269875">
               <a:spcAft>
                 <a:spcPts val="800"/>
               </a:spcAft>
@@ -29040,7 +29075,7 @@
                 </a:solidFill>
                 <a:latin typeface="Segoe UI"/>
               </a:rPr>
-              <a:t>▸  </a:t>
+              <a:t>▸	</a:t>
             </a:r>
             <a:r>
               <a:rPr sz="1700" b="0">
@@ -29049,7 +29084,7 @@
                 </a:solidFill>
                 <a:latin typeface="Segoe UI"/>
               </a:rPr>
-              <a:t>27 verificadores automáticos, 19 no hook de pre-commit: cada número da tese é recalculado a partir dos CSV, e o commit é recusado se algum deixar de bater</a:t>
+              <a:t>29 verificadores, 22 no hook de pre-commit: cada número da tese é recalculado dos CSV</a:t>
             </a:r>
           </a:p>
         </p:txBody>
@@ -29471,7 +29506,7 @@
           </a:bodyPr>
           <a:lstStyle/>
           <a:p>
-            <a:pPr algn="l">
+            <a:pPr algn="l" marL="238125" indent="-238125">
               <a:spcAft>
                 <a:spcPts val="800"/>
               </a:spcAft>
@@ -29483,7 +29518,7 @@
                 </a:solidFill>
                 <a:latin typeface="Segoe UI"/>
               </a:rPr>
-              <a:t>▸  </a:t>
+              <a:t>▸	</a:t>
             </a:r>
             <a:r>
               <a:rPr sz="1500" b="0">
@@ -30098,7 +30133,7 @@
           </a:bodyPr>
           <a:lstStyle/>
           <a:p>
-            <a:pPr algn="l">
+            <a:pPr algn="l" marL="269875" indent="-269875">
               <a:spcAft>
                 <a:spcPts val="800"/>
               </a:spcAft>
@@ -30110,7 +30145,7 @@
                 </a:solidFill>
                 <a:latin typeface="Segoe UI"/>
               </a:rPr>
-              <a:t>▸  </a:t>
+              <a:t>▸	</a:t>
             </a:r>
             <a:r>
               <a:rPr sz="1700" b="0">
@@ -30123,7 +30158,7 @@
             </a:r>
           </a:p>
           <a:p>
-            <a:pPr algn="l">
+            <a:pPr algn="l" marL="269875" indent="-269875">
               <a:spcAft>
                 <a:spcPts val="800"/>
               </a:spcAft>
@@ -30135,7 +30170,7 @@
                 </a:solidFill>
                 <a:latin typeface="Segoe UI"/>
               </a:rPr>
-              <a:t>▸  </a:t>
+              <a:t>▸	</a:t>
             </a:r>
             <a:r>
               <a:rPr sz="1700" b="0">
@@ -30148,7 +30183,7 @@
             </a:r>
           </a:p>
           <a:p>
-            <a:pPr algn="l">
+            <a:pPr algn="l" marL="269875" indent="-269875">
               <a:spcAft>
                 <a:spcPts val="800"/>
               </a:spcAft>
@@ -30160,7 +30195,7 @@
                 </a:solidFill>
                 <a:latin typeface="Segoe UI"/>
               </a:rPr>
-              <a:t>▸  </a:t>
+              <a:t>▸	</a:t>
             </a:r>
             <a:r>
               <a:rPr sz="1700" b="0">
@@ -30173,7 +30208,7 @@
             </a:r>
           </a:p>
           <a:p>
-            <a:pPr algn="l">
+            <a:pPr algn="l" marL="269875" indent="-269875">
               <a:spcAft>
                 <a:spcPts val="800"/>
               </a:spcAft>
@@ -30185,7 +30220,7 @@
                 </a:solidFill>
                 <a:latin typeface="Segoe UI"/>
               </a:rPr>
-              <a:t>▸  </a:t>
+              <a:t>▸	</a:t>
             </a:r>
             <a:r>
               <a:rPr sz="1700" b="0">

</xml_diff>

<commit_message>
feat(defesa): figuras próprias para projeção nos slides da QI1, bimodalidade e QI3
- Defesa/figuras_slides.py: as mesmas contas e CSV das figuras da tese, com
  letra de 15–17 pt e barras horizontais; confere 92–106 %, 59,8, 71,5 e 3/7
- slides 8, 9 e 13 passam a usar uma figura grande em vez de duas pequenas
- mapa de ocupação do GNN no Muro em U (tese e slide A5): o título longo saía
  cortado e empurrava o «(log)» da barra; nome curto, mapa igual byte a byte
</commit_message>
<xml_diff>
--- a/Defesa/slides_defesa.pptx
+++ b/Defesa/slides_defesa.pptx
@@ -12326,12 +12326,12 @@
         </p:nvSpPr>
         <p:spPr>
           <a:xfrm>
-            <a:off x="7003564" y="1600200"/>
-            <a:ext cx="3243942" cy="4206240"/>
+            <a:off x="5608015" y="1859362"/>
+            <a:ext cx="6035040" cy="4053676"/>
           </a:xfrm>
           <a:prstGeom prst="roundRect">
             <a:avLst>
-              <a:gd name="adj" fmla="val 2774"/>
+              <a:gd name="adj" fmla="val 1491"/>
             </a:avLst>
           </a:prstGeom>
           <a:solidFill>
@@ -12368,7 +12368,7 @@
       </p:sp>
       <p:pic>
         <p:nvPicPr>
-          <p:cNvPr id="9" name="Picture 8" descr="robustez_falhas.png"/>
+          <p:cNvPr id="9" name="Picture 8" descr="slide_robustez.png"/>
           <p:cNvPicPr>
             <a:picLocks noChangeAspect="1"/>
           </p:cNvPicPr>
@@ -12382,8 +12382,8 @@
         </p:blipFill>
         <p:spPr>
           <a:xfrm>
-            <a:off x="7085860" y="1682496"/>
-            <a:ext cx="3079350" cy="4041648"/>
+            <a:off x="5690311" y="1941658"/>
+            <a:ext cx="5870448" cy="3889084"/>
           </a:xfrm>
           <a:prstGeom prst="rect">
             <a:avLst/>
@@ -29493,7 +29493,7 @@
         <p:spPr>
           <a:xfrm>
             <a:off x="548640" y="1600200"/>
-            <a:ext cx="5608015" cy="4480560"/>
+            <a:ext cx="4693615" cy="4480560"/>
           </a:xfrm>
           <a:prstGeom prst="rect">
             <a:avLst/>
@@ -29652,12 +29652,12 @@
         </p:nvSpPr>
         <p:spPr>
           <a:xfrm>
-            <a:off x="7405849" y="1600200"/>
-            <a:ext cx="3353771" cy="2194560"/>
+            <a:off x="5608015" y="1810607"/>
+            <a:ext cx="6035040" cy="4151185"/>
           </a:xfrm>
           <a:prstGeom prst="roundRect">
             <a:avLst>
-              <a:gd name="adj" fmla="val 2683"/>
+              <a:gd name="adj" fmla="val 1491"/>
             </a:avLst>
           </a:prstGeom>
           <a:solidFill>
@@ -29694,7 +29694,7 @@
       </p:sp>
       <p:pic>
         <p:nvPicPr>
-          <p:cNvPr id="9" name="Picture 8" descr="taxa_sucesso_por_cenario.png"/>
+          <p:cNvPr id="9" name="Picture 8" descr="slide_qi1_chegadas.png"/>
           <p:cNvPicPr>
             <a:picLocks noChangeAspect="1"/>
           </p:cNvPicPr>
@@ -29708,80 +29708,8 @@
         </p:blipFill>
         <p:spPr>
           <a:xfrm>
-            <a:off x="7488145" y="1682496"/>
-            <a:ext cx="3189179" cy="2029968"/>
-          </a:xfrm>
-          <a:prstGeom prst="rect">
-            <a:avLst/>
-          </a:prstGeom>
-        </p:spPr>
-      </p:pic>
-      <p:sp>
-        <p:nvSpPr>
-          <p:cNvPr id="10" name="Rounded Rectangle 9"/>
-          <p:cNvSpPr/>
-          <p:nvPr/>
-        </p:nvSpPr>
-        <p:spPr>
-          <a:xfrm>
-            <a:off x="7221858" y="3977640"/>
-            <a:ext cx="3721753" cy="2194560"/>
-          </a:xfrm>
-          <a:prstGeom prst="roundRect">
-            <a:avLst>
-              <a:gd name="adj" fmla="val 2418"/>
-            </a:avLst>
-          </a:prstGeom>
-          <a:solidFill>
-            <a:srgbClr val="FFFFFF"/>
-          </a:solidFill>
-          <a:ln w="9525">
-            <a:solidFill>
-              <a:srgbClr val="2E2E2E"/>
-            </a:solidFill>
-          </a:ln>
-          <a:effectLst/>
-        </p:spPr>
-        <p:style>
-          <a:lnRef idx="1">
-            <a:schemeClr val="accent1"/>
-          </a:lnRef>
-          <a:fillRef idx="3">
-            <a:schemeClr val="accent1"/>
-          </a:fillRef>
-          <a:effectRef idx="2">
-            <a:schemeClr val="accent1"/>
-          </a:effectRef>
-          <a:fontRef idx="minor">
-            <a:schemeClr val="lt1"/>
-          </a:fontRef>
-        </p:style>
-        <p:txBody>
-          <a:bodyPr rtlCol="0" anchor="ctr"/>
-          <a:lstStyle/>
-          <a:p>
-            <a:pPr algn="ctr"/>
-          </a:p>
-        </p:txBody>
-      </p:sp>
-      <p:pic>
-        <p:nvPicPr>
-          <p:cNvPr id="11" name="Picture 10" descr="recolhas_por_cenario.png"/>
-          <p:cNvPicPr>
-            <a:picLocks noChangeAspect="1"/>
-          </p:cNvPicPr>
-          <p:nvPr/>
-        </p:nvPicPr>
-        <p:blipFill>
-          <a:blip r:embed="rId3"/>
-          <a:stretch>
-            <a:fillRect/>
-          </a:stretch>
-        </p:blipFill>
-        <p:spPr>
-          <a:xfrm>
-            <a:off x="7304154" y="4059936"/>
-            <a:ext cx="3557161" cy="2029968"/>
+            <a:off x="5690311" y="1892903"/>
+            <a:ext cx="5870448" cy="3986593"/>
           </a:xfrm>
           <a:prstGeom prst="rect">
             <a:avLst/>
@@ -29790,7 +29718,7 @@
       </p:pic>
       <p:cxnSp>
         <p:nvCxnSpPr>
-          <p:cNvPr id="12" name="Connector 11"/>
+          <p:cNvPr id="10" name="Connector 9"/>
           <p:cNvCxnSpPr/>
           <p:nvPr/>
         </p:nvCxnSpPr>
@@ -29825,7 +29753,7 @@
       </p:cxnSp>
       <p:sp>
         <p:nvSpPr>
-          <p:cNvPr id="13" name="TextBox 12"/>
+          <p:cNvPr id="11" name="TextBox 10"/>
           <p:cNvSpPr txBox="1"/>
           <p:nvPr/>
         </p:nvSpPr>
@@ -29864,7 +29792,7 @@
       </p:sp>
       <p:sp>
         <p:nvSpPr>
-          <p:cNvPr id="14" name="TextBox 13"/>
+          <p:cNvPr id="12" name="TextBox 11"/>
           <p:cNvSpPr txBox="1"/>
           <p:nvPr/>
         </p:nvSpPr>
@@ -30120,7 +30048,7 @@
         <p:spPr>
           <a:xfrm>
             <a:off x="548640" y="1600200"/>
-            <a:ext cx="5790895" cy="4480560"/>
+            <a:ext cx="4876495" cy="4480560"/>
           </a:xfrm>
           <a:prstGeom prst="rect">
             <a:avLst/>
@@ -30242,12 +30170,12 @@
         </p:nvSpPr>
         <p:spPr>
           <a:xfrm>
-            <a:off x="7860102" y="1600200"/>
-            <a:ext cx="2628145" cy="2194560"/>
+            <a:off x="5803338" y="1600200"/>
+            <a:ext cx="5827274" cy="4572000"/>
           </a:xfrm>
           <a:prstGeom prst="roundRect">
             <a:avLst>
-              <a:gd name="adj" fmla="val 3424"/>
+              <a:gd name="adj" fmla="val 1544"/>
             </a:avLst>
           </a:prstGeom>
           <a:solidFill>
@@ -30284,7 +30212,7 @@
       </p:sp>
       <p:pic>
         <p:nvPicPr>
-          <p:cNvPr id="9" name="Picture 8" descr="dotplot_eval_u_wall.png"/>
+          <p:cNvPr id="9" name="Picture 8" descr="slide_bimodal.png"/>
           <p:cNvPicPr>
             <a:picLocks noChangeAspect="1"/>
           </p:cNvPicPr>
@@ -30298,80 +30226,8 @@
         </p:blipFill>
         <p:spPr>
           <a:xfrm>
-            <a:off x="7942398" y="1682496"/>
-            <a:ext cx="2463553" cy="2029968"/>
-          </a:xfrm>
-          <a:prstGeom prst="rect">
-            <a:avLst/>
-          </a:prstGeom>
-        </p:spPr>
-      </p:pic>
-      <p:sp>
-        <p:nvSpPr>
-          <p:cNvPr id="10" name="Rounded Rectangle 9"/>
-          <p:cNvSpPr/>
-          <p:nvPr/>
-        </p:nvSpPr>
-        <p:spPr>
-          <a:xfrm>
-            <a:off x="7860102" y="3977640"/>
-            <a:ext cx="2628145" cy="2194560"/>
-          </a:xfrm>
-          <a:prstGeom prst="roundRect">
-            <a:avLst>
-              <a:gd name="adj" fmla="val 3424"/>
-            </a:avLst>
-          </a:prstGeom>
-          <a:solidFill>
-            <a:srgbClr val="FFFFFF"/>
-          </a:solidFill>
-          <a:ln w="9525">
-            <a:solidFill>
-              <a:srgbClr val="2E2E2E"/>
-            </a:solidFill>
-          </a:ln>
-          <a:effectLst/>
-        </p:spPr>
-        <p:style>
-          <a:lnRef idx="1">
-            <a:schemeClr val="accent1"/>
-          </a:lnRef>
-          <a:fillRef idx="3">
-            <a:schemeClr val="accent1"/>
-          </a:fillRef>
-          <a:effectRef idx="2">
-            <a:schemeClr val="accent1"/>
-          </a:effectRef>
-          <a:fontRef idx="minor">
-            <a:schemeClr val="lt1"/>
-          </a:fontRef>
-        </p:style>
-        <p:txBody>
-          <a:bodyPr rtlCol="0" anchor="ctr"/>
-          <a:lstStyle/>
-          <a:p>
-            <a:pPr algn="ctr"/>
-          </a:p>
-        </p:txBody>
-      </p:sp>
-      <p:pic>
-        <p:nvPicPr>
-          <p:cNvPr id="11" name="Picture 10" descr="dotplot_eval_none.png"/>
-          <p:cNvPicPr>
-            <a:picLocks noChangeAspect="1"/>
-          </p:cNvPicPr>
-          <p:nvPr/>
-        </p:nvPicPr>
-        <p:blipFill>
-          <a:blip r:embed="rId3"/>
-          <a:stretch>
-            <a:fillRect/>
-          </a:stretch>
-        </p:blipFill>
-        <p:spPr>
-          <a:xfrm>
-            <a:off x="7942398" y="4059936"/>
-            <a:ext cx="2463553" cy="2029968"/>
+            <a:off x="5885634" y="1682496"/>
+            <a:ext cx="5662682" cy="4407408"/>
           </a:xfrm>
           <a:prstGeom prst="rect">
             <a:avLst/>
@@ -30380,7 +30236,7 @@
       </p:pic>
       <p:cxnSp>
         <p:nvCxnSpPr>
-          <p:cNvPr id="12" name="Connector 11"/>
+          <p:cNvPr id="10" name="Connector 9"/>
           <p:cNvCxnSpPr/>
           <p:nvPr/>
         </p:nvCxnSpPr>
@@ -30415,7 +30271,7 @@
       </p:cxnSp>
       <p:sp>
         <p:nvSpPr>
-          <p:cNvPr id="13" name="TextBox 12"/>
+          <p:cNvPr id="11" name="TextBox 10"/>
           <p:cNvSpPr txBox="1"/>
           <p:nvPr/>
         </p:nvSpPr>
@@ -30454,7 +30310,7 @@
       </p:sp>
       <p:sp>
         <p:nvSpPr>
-          <p:cNvPr id="14" name="TextBox 13"/>
+          <p:cNvPr id="12" name="TextBox 11"/>
           <p:cNvSpPr txBox="1"/>
           <p:nvPr/>
         </p:nvSpPr>

</xml_diff>

<commit_message>
fix: o GNN do mapa composto treinou com a dosagem adaptativa — a tese deixa de a propor como trabalho futuro nesse mapa; artigo, notas dos slides e cábula dizem-no; o ranking da Overview e da Galeria salta o A1 contaminado das Quatro Salas; dotplots da tese iguais à fonte
</commit_message>
<xml_diff>
--- a/Defesa/slides_defesa.pptx
+++ b/Defesa/slides_defesa.pptx
@@ -1356,7 +1356,12 @@
           </a:p>
           <a:p>
             <a:r>
-              <a:t>pré-registado. Os três mapas mostram um episódio de cada: o evolutivo atravessa</a:t>
+              <a:t>pré-registado. E note-se: o evolutivo já treinou aqui com a novidade doseada</a:t>
+            </a:r>
+          </a:p>
+          <a:p>
+            <a:r>
+              <a:t>adaptativamente, o mecanismo que deu vinte e oito em vinte e oito no Muro em U. Os três mapas mostram um episódio de cada: o evolutivo atravessa</a:t>
             </a:r>
           </a:p>
           <a:p>

</xml_diff>